<commit_message>
Presäntation: Folien Zahlen angepasst
</commit_message>
<xml_diff>
--- a/Präsentation/Präsentation_Projekt/HHBKTendo_Praesentation_1.pptx
+++ b/Präsentation/Präsentation_Projekt/HHBKTendo_Praesentation_1.pptx
@@ -3356,8 +3356,8 @@
         </p:nvSpPr>
         <p:spPr>
           <a:xfrm>
-            <a:off x="8730005" y="4875028"/>
-            <a:ext cx="228600" cy="215444"/>
+            <a:off x="8630529" y="4868158"/>
+            <a:ext cx="328076" cy="215444"/>
           </a:xfrm>
           <a:prstGeom prst="rect">
             <a:avLst/>
@@ -3379,7 +3379,7 @@
                 <a:ea typeface="Calibri" pitchFamily="34" charset="-122"/>
                 <a:cs typeface="Calibri" pitchFamily="34" charset="-120"/>
               </a:rPr>
-              <a:t>9</a:t>
+              <a:t>10</a:t>
             </a:r>
             <a:endParaRPr lang="de-DE" sz="800" dirty="0"/>
           </a:p>
@@ -5657,7 +5657,7 @@
                 <a:ea typeface="Calibri" pitchFamily="34" charset="-122"/>
                 <a:cs typeface="Calibri" pitchFamily="34" charset="-120"/>
               </a:rPr>
-              <a:t>10</a:t>
+              <a:t>11</a:t>
             </a:r>
             <a:endParaRPr lang="de-DE" sz="800" dirty="0"/>
           </a:p>
@@ -6889,7 +6889,7 @@
           <a:p>
             <a:r>
               <a:rPr lang="de-DE" sz="800" dirty="0"/>
-              <a:t>11</a:t>
+              <a:t>12</a:t>
             </a:r>
           </a:p>
         </p:txBody>
@@ -8084,7 +8084,7 @@
         </p:nvSpPr>
         <p:spPr>
           <a:xfrm>
-            <a:off x="8633637" y="4875028"/>
+            <a:off x="8626603" y="4875028"/>
             <a:ext cx="332056" cy="215444"/>
           </a:xfrm>
           <a:prstGeom prst="rect">
@@ -8107,7 +8107,7 @@
                 <a:ea typeface="Calibri" pitchFamily="34" charset="-122"/>
                 <a:cs typeface="Calibri" pitchFamily="34" charset="-120"/>
               </a:rPr>
-              <a:t>12</a:t>
+              <a:t>13</a:t>
             </a:r>
             <a:endParaRPr lang="de-DE" sz="800" dirty="0"/>
           </a:p>
@@ -14511,7 +14511,7 @@
                 <a:ea typeface="Calibri" pitchFamily="34" charset="-122"/>
                 <a:cs typeface="Calibri" pitchFamily="34" charset="-120"/>
               </a:rPr>
-              <a:t>13</a:t>
+              <a:t>5</a:t>
             </a:r>
             <a:endParaRPr lang="de-DE" sz="800" dirty="0"/>
           </a:p>
@@ -15570,7 +15570,7 @@
                 <a:ea typeface="Calibri" pitchFamily="34" charset="-122"/>
                 <a:cs typeface="Calibri" pitchFamily="34" charset="-120"/>
               </a:rPr>
-              <a:t>5</a:t>
+              <a:t>6</a:t>
             </a:r>
             <a:endParaRPr lang="de-DE" sz="800" dirty="0"/>
           </a:p>
@@ -17000,12 +17000,12 @@
           <a:lstStyle/>
           <a:p>
             <a:r>
-              <a:rPr lang="en-US" sz="800">
+              <a:rPr lang="en-US" sz="800" dirty="0">
                 <a:latin typeface="Calibri" pitchFamily="34" charset="0"/>
                 <a:ea typeface="Calibri" pitchFamily="34" charset="-122"/>
                 <a:cs typeface="Calibri" pitchFamily="34" charset="-120"/>
               </a:rPr>
-              <a:t>6</a:t>
+              <a:t>7</a:t>
             </a:r>
             <a:endParaRPr lang="de-DE" sz="800" dirty="0"/>
           </a:p>
@@ -18071,7 +18071,7 @@
           <a:p>
             <a:r>
               <a:rPr lang="de-DE" sz="800" dirty="0"/>
-              <a:t>7</a:t>
+              <a:t>8</a:t>
             </a:r>
           </a:p>
         </p:txBody>
@@ -20416,7 +20416,7 @@
                 <a:ea typeface="Calibri" pitchFamily="34" charset="-122"/>
                 <a:cs typeface="Calibri" pitchFamily="34" charset="-120"/>
               </a:rPr>
-              <a:t>8</a:t>
+              <a:t>9</a:t>
             </a:r>
             <a:endParaRPr lang="de-DE" sz="800" dirty="0"/>
           </a:p>

</xml_diff>

<commit_message>
Updated Präsentation. Added Arda to end of presentation slide.
</commit_message>
<xml_diff>
--- a/Präsentation/Präsentation_Projekt/HHBKTendo_Praesentation_1.pptx
+++ b/Präsentation/Präsentation_Projekt/HHBKTendo_Praesentation_1.pptx
@@ -11,8 +11,8 @@
     <p:sldId id="256" r:id="rId2"/>
     <p:sldId id="257" r:id="rId3"/>
     <p:sldId id="258" r:id="rId4"/>
-    <p:sldId id="265" r:id="rId5"/>
-    <p:sldId id="262" r:id="rId6"/>
+    <p:sldId id="262" r:id="rId5"/>
+    <p:sldId id="265" r:id="rId6"/>
     <p:sldId id="266" r:id="rId7"/>
     <p:sldId id="259" r:id="rId8"/>
     <p:sldId id="267" r:id="rId9"/>
@@ -575,7 +575,7 @@
           <a:p>
             <a:fld id="{F7021451-1387-4CA6-816F-3879F97B5CBC}" type="slidenum">
               <a:rPr lang="en-US"/>
-              <a:t>5</a:t>
+              <a:t>4</a:t>
             </a:fld>
             <a:endParaRPr lang="en-US"/>
           </a:p>
@@ -1867,6 +1867,9 @@
           <a:solidFill>
             <a:srgbClr val="E94560"/>
           </a:solidFill>
+          <a:ln>
+            <a:solidFill/>
+          </a:ln>
         </p:spPr>
         <p:txBody>
           <a:bodyPr/>
@@ -3162,7 +3165,7 @@
           </a:solidFill>
           <a:ln w="6350">
             <a:solidFill>
-              <a:srgbClr val="2A3A5E"/>
+              <a:srgbClr val="D0D7E8"/>
             </a:solidFill>
             <a:prstDash val="solid"/>
           </a:ln>
@@ -3380,7 +3383,7 @@
             <a:r>
               <a:rPr lang="en-US" sz="800" dirty="0">
                 <a:solidFill>
-                  <a:srgbClr val="E94560"/>
+                  <a:srgbClr val="FFFFFF"/>
                 </a:solidFill>
                 <a:latin typeface="Calibri" pitchFamily="34" charset="0"/>
                 <a:ea typeface="Calibri" pitchFamily="34" charset="-122"/>
@@ -3406,7 +3409,7 @@
     <p:bg>
       <p:bgPr>
         <a:solidFill>
-          <a:srgbClr val="F0F4FF"/>
+          <a:srgbClr val="0D0D1A"/>
         </a:solidFill>
         <a:effectLst/>
       </p:bgPr>
@@ -3452,7 +3455,7 @@
             <a:r>
               <a:rPr lang="en-US" sz="2800" b="1" dirty="0">
                 <a:solidFill>
-                  <a:srgbClr val="1A1A2E"/>
+                  <a:srgbClr val="FFFFFF"/>
                 </a:solidFill>
                 <a:latin typeface="Arial Black" pitchFamily="34" charset="0"/>
                 <a:ea typeface="Arial Black" pitchFamily="34" charset="-122"/>
@@ -3518,7 +3521,7 @@
             <a:avLst/>
           </a:prstGeom>
           <a:solidFill>
-            <a:srgbClr val="FFFFFF"/>
+            <a:srgbClr val="161638"/>
           </a:solidFill>
           <a:ln w="12700">
             <a:solidFill>
@@ -3550,7 +3553,7 @@
             <a:avLst/>
           </a:prstGeom>
           <a:solidFill>
-            <a:srgbClr val="FFFFFF"/>
+            <a:srgbClr val="161638"/>
           </a:solidFill>
           <a:ln w="12700">
             <a:solidFill>
@@ -3582,7 +3585,7 @@
             <a:avLst/>
           </a:prstGeom>
           <a:solidFill>
-            <a:srgbClr val="FFFFFF"/>
+            <a:srgbClr val="161638"/>
           </a:solidFill>
           <a:ln w="12700">
             <a:solidFill>
@@ -3614,7 +3617,7 @@
             <a:avLst/>
           </a:prstGeom>
           <a:solidFill>
-            <a:srgbClr val="FFFFFF"/>
+            <a:srgbClr val="161638"/>
           </a:solidFill>
           <a:ln w="12700">
             <a:solidFill>
@@ -3646,7 +3649,7 @@
             <a:avLst/>
           </a:prstGeom>
           <a:solidFill>
-            <a:srgbClr val="FFFFFF"/>
+            <a:srgbClr val="161638"/>
           </a:solidFill>
           <a:ln w="12700">
             <a:solidFill>
@@ -3678,7 +3681,7 @@
             <a:avLst/>
           </a:prstGeom>
           <a:solidFill>
-            <a:srgbClr val="FFFFFF"/>
+            <a:srgbClr val="161638"/>
           </a:solidFill>
           <a:ln w="12700">
             <a:solidFill>
@@ -3710,7 +3713,7 @@
             <a:avLst/>
           </a:prstGeom>
           <a:solidFill>
-            <a:srgbClr val="FFFFFF"/>
+            <a:srgbClr val="161638"/>
           </a:solidFill>
           <a:ln w="12700">
             <a:solidFill>
@@ -3742,7 +3745,7 @@
             <a:avLst/>
           </a:prstGeom>
           <a:solidFill>
-            <a:srgbClr val="FFFFFF"/>
+            <a:srgbClr val="161638"/>
           </a:solidFill>
           <a:ln w="12700">
             <a:solidFill>
@@ -3774,7 +3777,7 @@
             <a:avLst/>
           </a:prstGeom>
           <a:solidFill>
-            <a:srgbClr val="FFFFFF"/>
+            <a:srgbClr val="161638"/>
           </a:solidFill>
           <a:ln w="12700">
             <a:solidFill>
@@ -3806,7 +3809,7 @@
             <a:avLst/>
           </a:prstGeom>
           <a:solidFill>
-            <a:srgbClr val="FFFFFF"/>
+            <a:srgbClr val="161638"/>
           </a:solidFill>
           <a:ln w="12700">
             <a:solidFill>
@@ -3838,7 +3841,7 @@
             <a:avLst/>
           </a:prstGeom>
           <a:solidFill>
-            <a:srgbClr val="FFFFFF"/>
+            <a:srgbClr val="161638"/>
           </a:solidFill>
           <a:ln w="12700">
             <a:solidFill>
@@ -3870,7 +3873,7 @@
             <a:avLst/>
           </a:prstGeom>
           <a:solidFill>
-            <a:srgbClr val="FFFFFF"/>
+            <a:srgbClr val="161638"/>
           </a:solidFill>
           <a:ln w="12700">
             <a:solidFill>
@@ -3902,7 +3905,7 @@
             <a:avLst/>
           </a:prstGeom>
           <a:solidFill>
-            <a:srgbClr val="FFFFFF"/>
+            <a:srgbClr val="161638"/>
           </a:solidFill>
           <a:ln w="12700">
             <a:solidFill>
@@ -3934,7 +3937,7 @@
             <a:avLst/>
           </a:prstGeom>
           <a:solidFill>
-            <a:srgbClr val="FFFFFF"/>
+            <a:srgbClr val="161638"/>
           </a:solidFill>
           <a:ln w="12700">
             <a:solidFill>
@@ -3966,7 +3969,7 @@
             <a:avLst/>
           </a:prstGeom>
           <a:solidFill>
-            <a:srgbClr val="FFFFFF"/>
+            <a:srgbClr val="161638"/>
           </a:solidFill>
           <a:ln w="12700">
             <a:solidFill>
@@ -3998,7 +4001,7 @@
             <a:avLst/>
           </a:prstGeom>
           <a:solidFill>
-            <a:srgbClr val="FFFFFF"/>
+            <a:srgbClr val="161638"/>
           </a:solidFill>
           <a:ln w="12700">
             <a:solidFill>
@@ -4030,7 +4033,7 @@
             <a:avLst/>
           </a:prstGeom>
           <a:solidFill>
-            <a:srgbClr val="FFFFFF"/>
+            <a:srgbClr val="161638"/>
           </a:solidFill>
           <a:ln w="12700">
             <a:solidFill>
@@ -4062,7 +4065,7 @@
             <a:avLst/>
           </a:prstGeom>
           <a:solidFill>
-            <a:srgbClr val="FFFFFF"/>
+            <a:srgbClr val="161638"/>
           </a:solidFill>
           <a:ln w="12700">
             <a:solidFill>
@@ -4094,7 +4097,7 @@
             <a:avLst/>
           </a:prstGeom>
           <a:solidFill>
-            <a:srgbClr val="FFFFFF"/>
+            <a:srgbClr val="161638"/>
           </a:solidFill>
           <a:ln w="12700">
             <a:solidFill>
@@ -4126,7 +4129,7 @@
             <a:avLst/>
           </a:prstGeom>
           <a:solidFill>
-            <a:srgbClr val="FFFFFF"/>
+            <a:srgbClr val="161638"/>
           </a:solidFill>
           <a:ln w="12700">
             <a:solidFill>
@@ -4158,7 +4161,7 @@
             <a:avLst/>
           </a:prstGeom>
           <a:solidFill>
-            <a:srgbClr val="FFFFFF"/>
+            <a:srgbClr val="161638"/>
           </a:solidFill>
           <a:ln w="12700">
             <a:solidFill>
@@ -4190,7 +4193,7 @@
             <a:avLst/>
           </a:prstGeom>
           <a:solidFill>
-            <a:srgbClr val="FFFFFF"/>
+            <a:srgbClr val="161638"/>
           </a:solidFill>
           <a:ln w="12700">
             <a:solidFill>
@@ -4222,7 +4225,7 @@
             <a:avLst/>
           </a:prstGeom>
           <a:solidFill>
-            <a:srgbClr val="FFFFFF"/>
+            <a:srgbClr val="161638"/>
           </a:solidFill>
           <a:ln w="12700">
             <a:solidFill>
@@ -4254,7 +4257,7 @@
             <a:avLst/>
           </a:prstGeom>
           <a:solidFill>
-            <a:srgbClr val="FFFFFF"/>
+            <a:srgbClr val="161638"/>
           </a:solidFill>
           <a:ln w="12700">
             <a:solidFill>
@@ -4286,7 +4289,7 @@
             <a:avLst/>
           </a:prstGeom>
           <a:solidFill>
-            <a:srgbClr val="FFFFFF"/>
+            <a:srgbClr val="161638"/>
           </a:solidFill>
           <a:ln w="12700">
             <a:solidFill>
@@ -4318,7 +4321,7 @@
             <a:avLst/>
           </a:prstGeom>
           <a:solidFill>
-            <a:srgbClr val="FFFFFF"/>
+            <a:srgbClr val="161638"/>
           </a:solidFill>
           <a:ln w="12700">
             <a:solidFill>
@@ -4350,7 +4353,7 @@
             <a:avLst/>
           </a:prstGeom>
           <a:solidFill>
-            <a:srgbClr val="FFFFFF"/>
+            <a:srgbClr val="161638"/>
           </a:solidFill>
           <a:ln w="12700">
             <a:solidFill>
@@ -4382,7 +4385,7 @@
             <a:avLst/>
           </a:prstGeom>
           <a:solidFill>
-            <a:srgbClr val="FFFFFF"/>
+            <a:srgbClr val="161638"/>
           </a:solidFill>
           <a:ln w="12700">
             <a:solidFill>
@@ -4414,7 +4417,7 @@
             <a:avLst/>
           </a:prstGeom>
           <a:solidFill>
-            <a:srgbClr val="FFFFFF"/>
+            <a:srgbClr val="161638"/>
           </a:solidFill>
           <a:ln w="12700">
             <a:solidFill>
@@ -4446,7 +4449,7 @@
             <a:avLst/>
           </a:prstGeom>
           <a:solidFill>
-            <a:srgbClr val="FFFFFF"/>
+            <a:srgbClr val="161638"/>
           </a:solidFill>
           <a:ln w="12700">
             <a:solidFill>
@@ -4478,7 +4481,7 @@
             <a:avLst/>
           </a:prstGeom>
           <a:solidFill>
-            <a:srgbClr val="FFFFFF"/>
+            <a:srgbClr val="161638"/>
           </a:solidFill>
           <a:ln w="12700">
             <a:solidFill>
@@ -4510,7 +4513,7 @@
             <a:avLst/>
           </a:prstGeom>
           <a:solidFill>
-            <a:srgbClr val="FFFFFF"/>
+            <a:srgbClr val="161638"/>
           </a:solidFill>
           <a:ln w="12700">
             <a:solidFill>
@@ -4542,7 +4545,7 @@
             <a:avLst/>
           </a:prstGeom>
           <a:solidFill>
-            <a:srgbClr val="FFFFFF"/>
+            <a:srgbClr val="161638"/>
           </a:solidFill>
           <a:ln w="12700">
             <a:solidFill>
@@ -4574,7 +4577,7 @@
             <a:avLst/>
           </a:prstGeom>
           <a:solidFill>
-            <a:srgbClr val="FFFFFF"/>
+            <a:srgbClr val="161638"/>
           </a:solidFill>
           <a:ln w="12700">
             <a:solidFill>
@@ -4606,7 +4609,7 @@
             <a:avLst/>
           </a:prstGeom>
           <a:solidFill>
-            <a:srgbClr val="FFFFFF"/>
+            <a:srgbClr val="161638"/>
           </a:solidFill>
           <a:ln w="12700">
             <a:solidFill>
@@ -4638,7 +4641,7 @@
             <a:avLst/>
           </a:prstGeom>
           <a:solidFill>
-            <a:srgbClr val="FFFFFF"/>
+            <a:srgbClr val="161638"/>
           </a:solidFill>
           <a:ln w="12700">
             <a:solidFill>
@@ -4982,7 +4985,7 @@
             <a:avLst/>
           </a:prstGeom>
           <a:solidFill>
-            <a:srgbClr val="FFFFFF"/>
+            <a:srgbClr val="161638"/>
           </a:solidFill>
           <a:ln w="6350">
             <a:solidFill>
@@ -5033,7 +5036,7 @@
             <a:r>
               <a:rPr lang="en-US" sz="1300" b="1" dirty="0">
                 <a:solidFill>
-                  <a:srgbClr val="1A1A2E"/>
+                  <a:srgbClr val="FFFFFF"/>
                 </a:solidFill>
                 <a:latin typeface="Calibri" pitchFamily="34" charset="0"/>
                 <a:ea typeface="Calibri" pitchFamily="34" charset="-122"/>
@@ -5072,7 +5075,7 @@
             <a:r>
               <a:rPr lang="en-US" sz="1100" dirty="0">
                 <a:solidFill>
-                  <a:srgbClr val="444444"/>
+                  <a:srgbClr val="D0D7E8"/>
                 </a:solidFill>
                 <a:latin typeface="Calibri" pitchFamily="34" charset="0"/>
                 <a:ea typeface="Calibri" pitchFamily="34" charset="-122"/>
@@ -5111,7 +5114,7 @@
             <a:r>
               <a:rPr lang="en-US" sz="1100" dirty="0">
                 <a:solidFill>
-                  <a:srgbClr val="444444"/>
+                  <a:srgbClr val="D0D7E8"/>
                 </a:solidFill>
                 <a:latin typeface="Calibri" pitchFamily="34" charset="0"/>
                 <a:ea typeface="Calibri" pitchFamily="34" charset="-122"/>
@@ -5150,7 +5153,7 @@
             <a:r>
               <a:rPr lang="en-US" sz="1100" dirty="0">
                 <a:solidFill>
-                  <a:srgbClr val="444444"/>
+                  <a:srgbClr val="D0D7E8"/>
                 </a:solidFill>
                 <a:latin typeface="Calibri" pitchFamily="34" charset="0"/>
                 <a:ea typeface="Calibri" pitchFamily="34" charset="-122"/>
@@ -5189,7 +5192,7 @@
             <a:r>
               <a:rPr lang="en-US" sz="1300" b="1" dirty="0">
                 <a:solidFill>
-                  <a:srgbClr val="1A1A2E"/>
+                  <a:srgbClr val="FFFFFF"/>
                 </a:solidFill>
                 <a:latin typeface="Calibri" pitchFamily="34" charset="0"/>
                 <a:ea typeface="Calibri" pitchFamily="34" charset="-122"/>
@@ -5228,7 +5231,7 @@
             <a:r>
               <a:rPr lang="en-US" sz="1100" dirty="0">
                 <a:solidFill>
-                  <a:srgbClr val="444444"/>
+                  <a:srgbClr val="D0D7E8"/>
                 </a:solidFill>
                 <a:latin typeface="Calibri" pitchFamily="34" charset="0"/>
                 <a:ea typeface="Calibri" pitchFamily="34" charset="-122"/>
@@ -5267,7 +5270,7 @@
             <a:r>
               <a:rPr lang="en-US" sz="1100" dirty="0">
                 <a:solidFill>
-                  <a:srgbClr val="444444"/>
+                  <a:srgbClr val="D0D7E8"/>
                 </a:solidFill>
                 <a:latin typeface="Calibri" pitchFamily="34" charset="0"/>
                 <a:ea typeface="Calibri" pitchFamily="34" charset="-122"/>
@@ -5306,7 +5309,7 @@
             <a:r>
               <a:rPr lang="en-US" sz="1100" dirty="0">
                 <a:solidFill>
-                  <a:srgbClr val="444444"/>
+                  <a:srgbClr val="D0D7E8"/>
                 </a:solidFill>
                 <a:latin typeface="Calibri" pitchFamily="34" charset="0"/>
                 <a:ea typeface="Calibri" pitchFamily="34" charset="-122"/>
@@ -5345,7 +5348,7 @@
             <a:r>
               <a:rPr lang="en-US" sz="1300" b="1" dirty="0">
                 <a:solidFill>
-                  <a:srgbClr val="1A1A2E"/>
+                  <a:srgbClr val="FFFFFF"/>
                 </a:solidFill>
                 <a:latin typeface="Calibri" pitchFamily="34" charset="0"/>
                 <a:ea typeface="Calibri" pitchFamily="34" charset="-122"/>
@@ -5384,7 +5387,7 @@
             <a:r>
               <a:rPr lang="en-US" sz="1100" dirty="0">
                 <a:solidFill>
-                  <a:srgbClr val="444444"/>
+                  <a:srgbClr val="D0D7E8"/>
                 </a:solidFill>
                 <a:latin typeface="Calibri" pitchFamily="34" charset="0"/>
                 <a:ea typeface="Calibri" pitchFamily="34" charset="-122"/>
@@ -5423,7 +5426,7 @@
             <a:r>
               <a:rPr lang="en-US" sz="1100" dirty="0">
                 <a:solidFill>
-                  <a:srgbClr val="444444"/>
+                  <a:srgbClr val="D0D7E8"/>
                 </a:solidFill>
                 <a:latin typeface="Calibri" pitchFamily="34" charset="0"/>
                 <a:ea typeface="Calibri" pitchFamily="34" charset="-122"/>
@@ -5462,7 +5465,7 @@
             <a:r>
               <a:rPr lang="en-US" sz="1100" dirty="0">
                 <a:solidFill>
-                  <a:srgbClr val="444444"/>
+                  <a:srgbClr val="D0D7E8"/>
                 </a:solidFill>
                 <a:latin typeface="Calibri" pitchFamily="34" charset="0"/>
                 <a:ea typeface="Calibri" pitchFamily="34" charset="-122"/>
@@ -5501,7 +5504,7 @@
             <a:r>
               <a:rPr lang="en-US" sz="1300" b="1" dirty="0">
                 <a:solidFill>
-                  <a:srgbClr val="1A1A2E"/>
+                  <a:srgbClr val="FFFFFF"/>
                 </a:solidFill>
                 <a:latin typeface="Calibri" pitchFamily="34" charset="0"/>
                 <a:ea typeface="Calibri" pitchFamily="34" charset="-122"/>
@@ -5540,7 +5543,7 @@
             <a:r>
               <a:rPr lang="en-US" sz="1100" dirty="0">
                 <a:solidFill>
-                  <a:srgbClr val="444444"/>
+                  <a:srgbClr val="D0D7E8"/>
                 </a:solidFill>
                 <a:latin typeface="Calibri" pitchFamily="34" charset="0"/>
                 <a:ea typeface="Calibri" pitchFamily="34" charset="-122"/>
@@ -5579,7 +5582,7 @@
             <a:r>
               <a:rPr lang="en-US" sz="1100" dirty="0">
                 <a:solidFill>
-                  <a:srgbClr val="444444"/>
+                  <a:srgbClr val="D0D7E8"/>
                 </a:solidFill>
                 <a:latin typeface="Calibri" pitchFamily="34" charset="0"/>
                 <a:ea typeface="Calibri" pitchFamily="34" charset="-122"/>
@@ -5618,7 +5621,7 @@
             <a:r>
               <a:rPr lang="en-US" sz="1100" dirty="0">
                 <a:solidFill>
-                  <a:srgbClr val="444444"/>
+                  <a:srgbClr val="D0D7E8"/>
                 </a:solidFill>
                 <a:latin typeface="Calibri" pitchFamily="34" charset="0"/>
                 <a:ea typeface="Calibri" pitchFamily="34" charset="-122"/>
@@ -5660,6 +5663,9 @@
           <a:p>
             <a:r>
               <a:rPr lang="en-US" sz="800" dirty="0">
+                <a:solidFill>
+                  <a:srgbClr val="FFFFFF"/>
+                </a:solidFill>
                 <a:latin typeface="Calibri" pitchFamily="34" charset="0"/>
                 <a:ea typeface="Calibri" pitchFamily="34" charset="-122"/>
                 <a:cs typeface="Calibri" pitchFamily="34" charset="-120"/>
@@ -5684,7 +5690,7 @@
     <p:bg>
       <p:bgPr>
         <a:solidFill>
-          <a:srgbClr val="F0F4FF"/>
+          <a:srgbClr val="0D0D1A"/>
         </a:solidFill>
         <a:effectLst/>
       </p:bgPr>
@@ -5720,6 +5726,9 @@
           <a:solidFill>
             <a:srgbClr val="4472C4"/>
           </a:solidFill>
+          <a:ln>
+            <a:solidFill/>
+          </a:ln>
         </p:spPr>
         <p:txBody>
           <a:bodyPr/>
@@ -5756,7 +5765,7 @@
             <a:r>
               <a:rPr lang="de-DE" sz="2800" b="1" dirty="0">
                 <a:solidFill>
-                  <a:srgbClr val="1A1A2E"/>
+                  <a:srgbClr val="FFFFFF"/>
                 </a:solidFill>
                 <a:latin typeface="Arial Black" pitchFamily="49" charset="0"/>
               </a:rPr>
@@ -6675,7 +6684,7 @@
             <a:avLst/>
           </a:prstGeom>
           <a:solidFill>
-            <a:srgbClr val="FFFFFF"/>
+            <a:srgbClr val="161638"/>
           </a:solidFill>
           <a:ln w="6350">
             <a:solidFill>
@@ -6719,7 +6728,7 @@
             <a:r>
               <a:rPr lang="de-DE" sz="1150" b="1" dirty="0">
                 <a:solidFill>
-                  <a:srgbClr val="2A3A5E"/>
+                  <a:srgbClr val="FFFFFF"/>
                 </a:solidFill>
                 <a:latin typeface="Calibri" pitchFamily="49" charset="0"/>
               </a:rPr>
@@ -6750,7 +6759,7 @@
             <a:r>
               <a:rPr lang="de-DE" sz="1150" b="1" dirty="0">
                 <a:solidFill>
-                  <a:srgbClr val="2A3A5E"/>
+                  <a:srgbClr val="FFFFFF"/>
                 </a:solidFill>
                 <a:latin typeface="Calibri" pitchFamily="49" charset="0"/>
               </a:rPr>
@@ -6781,7 +6790,7 @@
             <a:r>
               <a:rPr lang="de-DE" sz="1150" b="1" dirty="0">
                 <a:solidFill>
-                  <a:srgbClr val="2A3A5E"/>
+                  <a:srgbClr val="FFFFFF"/>
                 </a:solidFill>
                 <a:latin typeface="Calibri" pitchFamily="49" charset="0"/>
               </a:rPr>
@@ -6812,7 +6821,7 @@
             <a:r>
               <a:rPr lang="de-DE" sz="1150" b="1" dirty="0">
                 <a:solidFill>
-                  <a:srgbClr val="2A3A5E"/>
+                  <a:srgbClr val="FFFFFF"/>
                 </a:solidFill>
                 <a:latin typeface="Calibri" pitchFamily="49" charset="0"/>
               </a:rPr>
@@ -6843,7 +6852,7 @@
             <a:r>
               <a:rPr lang="de-DE" sz="1150" b="1" dirty="0">
                 <a:solidFill>
-                  <a:srgbClr val="2A3A5E"/>
+                  <a:srgbClr val="FFFFFF"/>
                 </a:solidFill>
                 <a:latin typeface="Calibri" pitchFamily="49" charset="0"/>
               </a:rPr>
@@ -6895,7 +6904,11 @@
           <a:lstStyle/>
           <a:p>
             <a:r>
-              <a:rPr lang="de-DE" sz="800" dirty="0"/>
+              <a:rPr lang="de-DE" sz="800" dirty="0">
+                <a:solidFill>
+                  <a:srgbClr val="FFFFFF"/>
+                </a:solidFill>
+              </a:rPr>
               <a:t>12</a:t>
             </a:r>
           </a:p>
@@ -6951,6 +6964,9 @@
           <a:solidFill>
             <a:srgbClr val="E94560"/>
           </a:solidFill>
+          <a:ln>
+            <a:solidFill/>
+          </a:ln>
         </p:spPr>
         <p:txBody>
           <a:bodyPr/>
@@ -7890,7 +7906,7 @@
           </a:solidFill>
           <a:ln w="6350">
             <a:solidFill>
-              <a:srgbClr val="2A3A5E"/>
+              <a:srgbClr val="D0D7E8"/>
             </a:solidFill>
             <a:prstDash val="solid"/>
           </a:ln>
@@ -8108,7 +8124,7 @@
             <a:r>
               <a:rPr lang="en-US" sz="800" dirty="0">
                 <a:solidFill>
-                  <a:srgbClr val="E94560"/>
+                  <a:srgbClr val="FFFFFF"/>
                 </a:solidFill>
                 <a:latin typeface="Calibri" pitchFamily="34" charset="0"/>
                 <a:ea typeface="Calibri" pitchFamily="34" charset="-122"/>
@@ -8134,7 +8150,7 @@
     <p:bg>
       <p:bgPr>
         <a:solidFill>
-          <a:srgbClr val="F0F4FF"/>
+          <a:srgbClr val="0D0D1A"/>
         </a:solidFill>
         <a:effectLst/>
       </p:bgPr>
@@ -8180,7 +8196,7 @@
             <a:r>
               <a:rPr lang="en-US" sz="2800" b="1" dirty="0">
                 <a:solidFill>
-                  <a:srgbClr val="1A1A2E"/>
+                  <a:srgbClr val="FFFFFF"/>
                 </a:solidFill>
                 <a:latin typeface="Arial Black" pitchFamily="34" charset="0"/>
                 <a:ea typeface="Arial Black" pitchFamily="34" charset="-122"/>
@@ -8246,7 +8262,7 @@
             <a:avLst/>
           </a:prstGeom>
           <a:solidFill>
-            <a:srgbClr val="FFFFFF"/>
+            <a:srgbClr val="161638"/>
           </a:solidFill>
           <a:ln w="6350">
             <a:solidFill>
@@ -8368,7 +8384,7 @@
             <a:r>
               <a:rPr lang="en-US" sz="1300" b="1" dirty="0">
                 <a:solidFill>
-                  <a:srgbClr val="1A1A2E"/>
+                  <a:srgbClr val="FFFFFF"/>
                 </a:solidFill>
                 <a:latin typeface="Calibri" pitchFamily="34" charset="0"/>
                 <a:ea typeface="Calibri" pitchFamily="34" charset="-122"/>
@@ -8407,7 +8423,7 @@
             <a:r>
               <a:rPr lang="en-US" sz="1100" dirty="0">
                 <a:solidFill>
-                  <a:srgbClr val="555555"/>
+                  <a:srgbClr val="D0D7E8"/>
                 </a:solidFill>
                 <a:latin typeface="Calibri" pitchFamily="34" charset="0"/>
                 <a:ea typeface="Calibri" pitchFamily="34" charset="-122"/>
@@ -8434,7 +8450,7 @@
             <a:avLst/>
           </a:prstGeom>
           <a:solidFill>
-            <a:srgbClr val="FFFFFF"/>
+            <a:srgbClr val="161638"/>
           </a:solidFill>
           <a:ln w="6350">
             <a:solidFill>
@@ -8556,7 +8572,7 @@
             <a:r>
               <a:rPr lang="en-US" sz="1300" b="1" dirty="0">
                 <a:solidFill>
-                  <a:srgbClr val="1A1A2E"/>
+                  <a:srgbClr val="FFFFFF"/>
                 </a:solidFill>
                 <a:latin typeface="Calibri" pitchFamily="34" charset="0"/>
                 <a:ea typeface="Calibri" pitchFamily="34" charset="-122"/>
@@ -8595,7 +8611,7 @@
             <a:r>
               <a:rPr lang="en-US" sz="1100" dirty="0">
                 <a:solidFill>
-                  <a:srgbClr val="555555"/>
+                  <a:srgbClr val="D0D7E8"/>
                 </a:solidFill>
                 <a:latin typeface="Calibri" pitchFamily="34" charset="0"/>
                 <a:ea typeface="Calibri" pitchFamily="34" charset="-122"/>
@@ -8622,7 +8638,7 @@
             <a:avLst/>
           </a:prstGeom>
           <a:solidFill>
-            <a:srgbClr val="FFFFFF"/>
+            <a:srgbClr val="161638"/>
           </a:solidFill>
           <a:ln w="6350">
             <a:solidFill>
@@ -8744,7 +8760,7 @@
             <a:r>
               <a:rPr lang="en-US" sz="1300" b="1" dirty="0">
                 <a:solidFill>
-                  <a:srgbClr val="1A1A2E"/>
+                  <a:srgbClr val="FFFFFF"/>
                 </a:solidFill>
                 <a:latin typeface="Calibri" pitchFamily="34" charset="0"/>
                 <a:ea typeface="Calibri" pitchFamily="34" charset="-122"/>
@@ -8783,7 +8799,7 @@
             <a:r>
               <a:rPr lang="en-US" sz="1100" dirty="0">
                 <a:solidFill>
-                  <a:srgbClr val="555555"/>
+                  <a:srgbClr val="D0D7E8"/>
                 </a:solidFill>
                 <a:latin typeface="Calibri" pitchFamily="34" charset="0"/>
                 <a:ea typeface="Calibri" pitchFamily="34" charset="-122"/>
@@ -8810,7 +8826,7 @@
             <a:avLst/>
           </a:prstGeom>
           <a:solidFill>
-            <a:srgbClr val="FFFFFF"/>
+            <a:srgbClr val="161638"/>
           </a:solidFill>
           <a:ln w="6350">
             <a:solidFill>
@@ -8932,7 +8948,7 @@
             <a:r>
               <a:rPr lang="en-US" sz="1300" b="1" dirty="0">
                 <a:solidFill>
-                  <a:srgbClr val="1A1A2E"/>
+                  <a:srgbClr val="FFFFFF"/>
                 </a:solidFill>
                 <a:latin typeface="Calibri" pitchFamily="34" charset="0"/>
                 <a:ea typeface="Calibri" pitchFamily="34" charset="-122"/>
@@ -8971,7 +8987,7 @@
             <a:r>
               <a:rPr lang="en-US" sz="1100" dirty="0">
                 <a:solidFill>
-                  <a:srgbClr val="555555"/>
+                  <a:srgbClr val="D0D7E8"/>
                 </a:solidFill>
                 <a:latin typeface="Calibri" pitchFamily="34" charset="0"/>
                 <a:ea typeface="Calibri" pitchFamily="34" charset="-122"/>
@@ -8998,7 +9014,7 @@
             <a:avLst/>
           </a:prstGeom>
           <a:solidFill>
-            <a:srgbClr val="FFFFFF"/>
+            <a:srgbClr val="161638"/>
           </a:solidFill>
           <a:ln w="6350">
             <a:solidFill>
@@ -9120,7 +9136,7 @@
             <a:r>
               <a:rPr lang="en-US" sz="1300" b="1" dirty="0">
                 <a:solidFill>
-                  <a:srgbClr val="1A1A2E"/>
+                  <a:srgbClr val="FFFFFF"/>
                 </a:solidFill>
                 <a:latin typeface="Calibri" pitchFamily="34" charset="0"/>
                 <a:ea typeface="Calibri" pitchFamily="34" charset="-122"/>
@@ -9159,7 +9175,7 @@
             <a:r>
               <a:rPr lang="en-US" sz="1100" dirty="0">
                 <a:solidFill>
-                  <a:srgbClr val="555555"/>
+                  <a:srgbClr val="D0D7E8"/>
                 </a:solidFill>
                 <a:latin typeface="Calibri" pitchFamily="34" charset="0"/>
                 <a:ea typeface="Calibri" pitchFamily="34" charset="-122"/>
@@ -9186,7 +9202,7 @@
             <a:avLst/>
           </a:prstGeom>
           <a:solidFill>
-            <a:srgbClr val="FFFFFF"/>
+            <a:srgbClr val="161638"/>
           </a:solidFill>
           <a:ln w="6350">
             <a:solidFill>
@@ -9308,7 +9324,7 @@
             <a:r>
               <a:rPr lang="en-US" sz="1300" b="1" dirty="0">
                 <a:solidFill>
-                  <a:srgbClr val="1A1A2E"/>
+                  <a:srgbClr val="FFFFFF"/>
                 </a:solidFill>
                 <a:latin typeface="Calibri" pitchFamily="34" charset="0"/>
                 <a:ea typeface="Calibri" pitchFamily="34" charset="-122"/>
@@ -9347,7 +9363,7 @@
             <a:r>
               <a:rPr lang="en-US" sz="1100" dirty="0">
                 <a:solidFill>
-                  <a:srgbClr val="555555"/>
+                  <a:srgbClr val="D0D7E8"/>
                 </a:solidFill>
                 <a:latin typeface="Calibri" pitchFamily="34" charset="0"/>
                 <a:ea typeface="Calibri" pitchFamily="34" charset="-122"/>
@@ -9389,6 +9405,9 @@
           <a:p>
             <a:r>
               <a:rPr lang="en-US" sz="800" dirty="0">
+                <a:solidFill>
+                  <a:srgbClr val="FFFFFF"/>
+                </a:solidFill>
                 <a:latin typeface="Calibri" pitchFamily="34" charset="0"/>
                 <a:ea typeface="Calibri" pitchFamily="34" charset="-122"/>
                 <a:cs typeface="Calibri" pitchFamily="34" charset="-120"/>
@@ -9413,7 +9432,7 @@
     <p:bg>
       <p:bgPr>
         <a:solidFill>
-          <a:srgbClr val="F0F4FF"/>
+          <a:srgbClr val="0D0D1A"/>
         </a:solidFill>
         <a:effectLst/>
       </p:bgPr>
@@ -9449,6 +9468,9 @@
           <a:solidFill>
             <a:srgbClr val="4472C4"/>
           </a:solidFill>
+          <a:ln>
+            <a:solidFill/>
+          </a:ln>
         </p:spPr>
         <p:txBody>
           <a:bodyPr/>
@@ -9485,7 +9507,7 @@
             <a:r>
               <a:rPr lang="de-DE" sz="2800" b="1" dirty="0">
                 <a:solidFill>
-                  <a:srgbClr val="1A1A2E"/>
+                  <a:srgbClr val="FFFFFF"/>
                 </a:solidFill>
                 <a:latin typeface="Arial Black" pitchFamily="49" charset="0"/>
               </a:rPr>
@@ -10342,7 +10364,7 @@
             <a:avLst/>
           </a:prstGeom>
           <a:solidFill>
-            <a:srgbClr val="FFFFFF"/>
+            <a:srgbClr val="161638"/>
           </a:solidFill>
           <a:ln w="6350">
             <a:solidFill>
@@ -10386,7 +10408,7 @@
             <a:r>
               <a:rPr lang="de-DE" sz="1150" b="1" dirty="0">
                 <a:solidFill>
-                  <a:srgbClr val="2A3A5E"/>
+                  <a:srgbClr val="FFFFFF"/>
                 </a:solidFill>
                 <a:latin typeface="Calibri"/>
               </a:rPr>
@@ -10410,7 +10432,7 @@
             <a:r>
               <a:rPr lang="de-DE" sz="1150" b="1" dirty="0">
                 <a:solidFill>
-                  <a:srgbClr val="2A3A5E"/>
+                  <a:srgbClr val="FFFFFF"/>
                 </a:solidFill>
                 <a:latin typeface="Calibri"/>
               </a:rPr>
@@ -10434,7 +10456,7 @@
             <a:r>
               <a:rPr lang="de-DE" sz="1150" b="1" dirty="0">
                 <a:solidFill>
-                  <a:srgbClr val="2A3A5E"/>
+                  <a:srgbClr val="FFFFFF"/>
                 </a:solidFill>
                 <a:latin typeface="Calibri"/>
               </a:rPr>
@@ -10458,7 +10480,7 @@
             <a:r>
               <a:rPr lang="de-DE" sz="1150" b="1" dirty="0">
                 <a:solidFill>
-                  <a:srgbClr val="2A3A5E"/>
+                  <a:srgbClr val="FFFFFF"/>
                 </a:solidFill>
                 <a:latin typeface="Calibri"/>
               </a:rPr>
@@ -10482,7 +10504,7 @@
             <a:r>
               <a:rPr lang="de-DE" sz="1150" b="1" dirty="0">
                 <a:solidFill>
-                  <a:srgbClr val="2A3A5E"/>
+                  <a:srgbClr val="FFFFFF"/>
                 </a:solidFill>
                 <a:latin typeface="Calibri"/>
               </a:rPr>
@@ -10530,7 +10552,11 @@
           <a:lstStyle/>
           <a:p>
             <a:r>
-              <a:rPr lang="de-DE" sz="800" dirty="0"/>
+              <a:rPr lang="de-DE" sz="800" dirty="0">
+                <a:solidFill>
+                  <a:srgbClr val="FFFFFF"/>
+                </a:solidFill>
+              </a:rPr>
               <a:t>15</a:t>
             </a:r>
           </a:p>
@@ -10625,9 +10651,9 @@
           <a:solidFill>
             <a:srgbClr val="1E2A4A"/>
           </a:solidFill>
-          <a:ln w="3810">
+          <a:ln w="6350">
             <a:solidFill>
-              <a:srgbClr val="2A3A5E"/>
+              <a:srgbClr val="D0D7E8"/>
             </a:solidFill>
             <a:prstDash val="solid"/>
           </a:ln>
@@ -10667,7 +10693,7 @@
             <a:r>
               <a:rPr lang="en-US" sz="1700" dirty="0">
                 <a:solidFill>
-                  <a:srgbClr val="000000"/>
+                  <a:srgbClr val="2ECC71"/>
                 </a:solidFill>
               </a:rPr>
               <a:t>✅</a:t>
@@ -10732,9 +10758,9 @@
           <a:solidFill>
             <a:srgbClr val="1E2A4A"/>
           </a:solidFill>
-          <a:ln w="3810">
+          <a:ln w="6350">
             <a:solidFill>
-              <a:srgbClr val="2A3A5E"/>
+              <a:srgbClr val="D0D7E8"/>
             </a:solidFill>
             <a:prstDash val="solid"/>
           </a:ln>
@@ -10774,7 +10800,7 @@
             <a:r>
               <a:rPr lang="en-US" sz="1700" dirty="0">
                 <a:solidFill>
-                  <a:srgbClr val="000000"/>
+                  <a:srgbClr val="2ECC71"/>
                 </a:solidFill>
               </a:rPr>
               <a:t>🤖</a:t>
@@ -10839,9 +10865,9 @@
           <a:solidFill>
             <a:srgbClr val="1E2A4A"/>
           </a:solidFill>
-          <a:ln w="3810">
+          <a:ln w="6350">
             <a:solidFill>
-              <a:srgbClr val="2A3A5E"/>
+              <a:srgbClr val="D0D7E8"/>
             </a:solidFill>
             <a:prstDash val="solid"/>
           </a:ln>
@@ -10881,7 +10907,7 @@
             <a:r>
               <a:rPr lang="en-US" sz="1700" dirty="0">
                 <a:solidFill>
-                  <a:srgbClr val="000000"/>
+                  <a:srgbClr val="2ECC71"/>
                 </a:solidFill>
               </a:rPr>
               <a:t>🔒</a:t>
@@ -10946,9 +10972,9 @@
           <a:solidFill>
             <a:srgbClr val="1E2A4A"/>
           </a:solidFill>
-          <a:ln w="3810">
+          <a:ln w="6350">
             <a:solidFill>
-              <a:srgbClr val="2A3A5E"/>
+              <a:srgbClr val="D0D7E8"/>
             </a:solidFill>
             <a:prstDash val="solid"/>
           </a:ln>
@@ -10988,7 +11014,7 @@
             <a:r>
               <a:rPr lang="en-US" sz="1700" dirty="0">
                 <a:solidFill>
-                  <a:srgbClr val="000000"/>
+                  <a:srgbClr val="2ECC71"/>
                 </a:solidFill>
               </a:rPr>
               <a:t>📦</a:t>
@@ -11053,9 +11079,9 @@
           <a:solidFill>
             <a:srgbClr val="1E2A4A"/>
           </a:solidFill>
-          <a:ln w="3810">
+          <a:ln w="6350">
             <a:solidFill>
-              <a:srgbClr val="2A3A5E"/>
+              <a:srgbClr val="D0D7E8"/>
             </a:solidFill>
             <a:prstDash val="solid"/>
           </a:ln>
@@ -11095,7 +11121,7 @@
             <a:r>
               <a:rPr lang="en-US" sz="1700" dirty="0">
                 <a:solidFill>
-                  <a:srgbClr val="000000"/>
+                  <a:srgbClr val="2ECC71"/>
                 </a:solidFill>
               </a:rPr>
               <a:t>🖥️</a:t>
@@ -11160,9 +11186,9 @@
           <a:solidFill>
             <a:srgbClr val="1E2A4A"/>
           </a:solidFill>
-          <a:ln w="3810">
+          <a:ln w="6350">
             <a:solidFill>
-              <a:srgbClr val="2A3A5E"/>
+              <a:srgbClr val="D0D7E8"/>
             </a:solidFill>
             <a:prstDash val="solid"/>
           </a:ln>
@@ -11202,7 +11228,7 @@
             <a:r>
               <a:rPr lang="en-US" sz="1700" dirty="0">
                 <a:solidFill>
-                  <a:srgbClr val="000000"/>
+                  <a:srgbClr val="2ECC71"/>
                 </a:solidFill>
               </a:rPr>
               <a:t>🧪</a:t>
@@ -11281,7 +11307,7 @@
             <a:r>
               <a:rPr lang="de-DE" sz="800" dirty="0">
                 <a:solidFill>
-                  <a:srgbClr val="1E2A4A"/>
+                  <a:srgbClr val="FFFFFF"/>
                 </a:solidFill>
               </a:rPr>
               <a:t>16</a:t>
@@ -11416,7 +11442,7 @@
             <a:r>
               <a:rPr sz="800" b="1">
                 <a:solidFill>
-                  <a:srgbClr val="E94560"/>
+                  <a:srgbClr val="FFFFFF"/>
                 </a:solidFill>
               </a:rPr>
               <a:t>17</a:t>
@@ -11441,8 +11467,10 @@
           <a:solidFill>
             <a:srgbClr val="161638"/>
           </a:solidFill>
-          <a:ln>
-            <a:noFill/>
+          <a:ln w="6350">
+            <a:solidFill>
+              <a:srgbClr val="D0D7E8"/>
+            </a:solidFill>
           </a:ln>
         </p:spPr>
         <p:style>
@@ -11486,7 +11514,7 @@
             <a:srgbClr val="2ECC71"/>
           </a:solidFill>
           <a:ln>
-            <a:noFill/>
+            <a:solidFill/>
           </a:ln>
         </p:spPr>
         <p:style>
@@ -11630,8 +11658,10 @@
           <a:solidFill>
             <a:srgbClr val="161638"/>
           </a:solidFill>
-          <a:ln>
-            <a:noFill/>
+          <a:ln w="6350">
+            <a:solidFill>
+              <a:srgbClr val="D0D7E8"/>
+            </a:solidFill>
           </a:ln>
         </p:spPr>
         <p:style>
@@ -11666,7 +11696,7 @@
         <p:spPr>
           <a:xfrm>
             <a:off x="365760" y="2570000"/>
-            <a:ext cx="75000" cy="1065028"/>
+            <a:ext cx="64008" cy="1065028"/>
           </a:xfrm>
           <a:prstGeom prst="rect">
             <a:avLst/>
@@ -11675,7 +11705,7 @@
             <a:srgbClr val="4472C4"/>
           </a:solidFill>
           <a:ln>
-            <a:noFill/>
+            <a:solidFill/>
           </a:ln>
         </p:spPr>
         <p:style>
@@ -11797,8 +11827,10 @@
           <a:solidFill>
             <a:srgbClr val="161638"/>
           </a:solidFill>
-          <a:ln>
-            <a:noFill/>
+          <a:ln w="6350">
+            <a:solidFill>
+              <a:srgbClr val="D0D7E8"/>
+            </a:solidFill>
           </a:ln>
         </p:spPr>
         <p:style>
@@ -11833,7 +11865,7 @@
         <p:spPr>
           <a:xfrm>
             <a:off x="4846320" y="2570000"/>
-            <a:ext cx="75000" cy="1065028"/>
+            <a:ext cx="64008" cy="1065028"/>
           </a:xfrm>
           <a:prstGeom prst="rect">
             <a:avLst/>
@@ -11842,7 +11874,7 @@
             <a:srgbClr val="F39C12"/>
           </a:solidFill>
           <a:ln>
-            <a:noFill/>
+            <a:solidFill/>
           </a:ln>
         </p:spPr>
         <p:style>
@@ -11986,8 +12018,10 @@
           <a:solidFill>
             <a:srgbClr val="141432"/>
           </a:solidFill>
-          <a:ln>
-            <a:noFill/>
+          <a:ln w="6350">
+            <a:solidFill>
+              <a:srgbClr val="D0D7E8"/>
+            </a:solidFill>
           </a:ln>
         </p:spPr>
         <p:style>
@@ -12283,7 +12317,7 @@
             <a:r>
               <a:rPr sz="800" b="1" dirty="0">
                 <a:solidFill>
-                  <a:srgbClr val="E94560"/>
+                  <a:srgbClr val="FFFFFF"/>
                 </a:solidFill>
               </a:rPr>
               <a:t>18</a:t>
@@ -12308,8 +12342,10 @@
           <a:solidFill>
             <a:srgbClr val="1A1A45"/>
           </a:solidFill>
-          <a:ln>
-            <a:noFill/>
+          <a:ln w="6350">
+            <a:solidFill>
+              <a:srgbClr val="D0D7E8"/>
+            </a:solidFill>
           </a:ln>
         </p:spPr>
         <p:style>
@@ -12488,8 +12524,10 @@
           <a:solidFill>
             <a:srgbClr val="141432"/>
           </a:solidFill>
-          <a:ln>
-            <a:noFill/>
+          <a:ln w="6350">
+            <a:solidFill>
+              <a:srgbClr val="D0D7E8"/>
+            </a:solidFill>
           </a:ln>
         </p:spPr>
         <p:style>
@@ -12533,7 +12571,7 @@
             <a:srgbClr val="2ECC71"/>
           </a:solidFill>
           <a:ln>
-            <a:noFill/>
+            <a:solidFill/>
           </a:ln>
         </p:spPr>
         <p:style>
@@ -12734,8 +12772,10 @@
           <a:solidFill>
             <a:srgbClr val="161638"/>
           </a:solidFill>
-          <a:ln>
-            <a:noFill/>
+          <a:ln w="6350">
+            <a:solidFill>
+              <a:srgbClr val="D0D7E8"/>
+            </a:solidFill>
           </a:ln>
         </p:spPr>
         <p:style>
@@ -12779,7 +12819,7 @@
             <a:srgbClr val="F1C40F"/>
           </a:solidFill>
           <a:ln>
-            <a:noFill/>
+            <a:solidFill/>
           </a:ln>
         </p:spPr>
         <p:style>
@@ -12980,8 +13020,10 @@
           <a:solidFill>
             <a:srgbClr val="141432"/>
           </a:solidFill>
-          <a:ln>
-            <a:noFill/>
+          <a:ln w="6350">
+            <a:solidFill>
+              <a:srgbClr val="D0D7E8"/>
+            </a:solidFill>
           </a:ln>
         </p:spPr>
         <p:style>
@@ -13025,7 +13067,7 @@
             <a:srgbClr val="F1C40F"/>
           </a:solidFill>
           <a:ln>
-            <a:noFill/>
+            <a:solidFill/>
           </a:ln>
         </p:spPr>
         <p:style>
@@ -13226,8 +13268,10 @@
           <a:solidFill>
             <a:srgbClr val="161638"/>
           </a:solidFill>
-          <a:ln>
-            <a:noFill/>
+          <a:ln w="6350">
+            <a:solidFill>
+              <a:srgbClr val="D0D7E8"/>
+            </a:solidFill>
           </a:ln>
         </p:spPr>
         <p:style>
@@ -13271,7 +13315,7 @@
             <a:srgbClr val="F1C40F"/>
           </a:solidFill>
           <a:ln>
-            <a:noFill/>
+            <a:solidFill/>
           </a:ln>
         </p:spPr>
         <p:style>
@@ -13472,8 +13516,10 @@
           <a:solidFill>
             <a:srgbClr val="141432"/>
           </a:solidFill>
-          <a:ln>
-            <a:noFill/>
+          <a:ln w="6350">
+            <a:solidFill>
+              <a:srgbClr val="D0D7E8"/>
+            </a:solidFill>
           </a:ln>
         </p:spPr>
         <p:style>
@@ -13517,7 +13563,7 @@
             <a:srgbClr val="2ECC71"/>
           </a:solidFill>
           <a:ln>
-            <a:noFill/>
+            <a:solidFill/>
           </a:ln>
         </p:spPr>
         <p:style>
@@ -13851,7 +13897,7 @@
             <a:r>
               <a:rPr sz="800" b="1" dirty="0">
                 <a:solidFill>
-                  <a:srgbClr val="E94560"/>
+                  <a:srgbClr val="FFFFFF"/>
                 </a:solidFill>
               </a:rPr>
               <a:t>19</a:t>
@@ -13876,8 +13922,10 @@
           <a:solidFill>
             <a:srgbClr val="161638"/>
           </a:solidFill>
-          <a:ln>
-            <a:noFill/>
+          <a:ln w="6350">
+            <a:solidFill>
+              <a:srgbClr val="D0D7E8"/>
+            </a:solidFill>
           </a:ln>
         </p:spPr>
         <p:style>
@@ -13921,7 +13969,7 @@
             <a:srgbClr val="4472C4"/>
           </a:solidFill>
           <a:ln>
-            <a:noFill/>
+            <a:solidFill/>
           </a:ln>
         </p:spPr>
         <p:style>
@@ -14177,8 +14225,10 @@
           <a:solidFill>
             <a:srgbClr val="161638"/>
           </a:solidFill>
-          <a:ln>
-            <a:noFill/>
+          <a:ln w="6350">
+            <a:solidFill>
+              <a:srgbClr val="D0D7E8"/>
+            </a:solidFill>
           </a:ln>
         </p:spPr>
         <p:style>
@@ -14222,7 +14272,7 @@
             <a:srgbClr val="E94560"/>
           </a:solidFill>
           <a:ln>
-            <a:noFill/>
+            <a:solidFill/>
           </a:ln>
         </p:spPr>
         <p:style>
@@ -14377,8 +14427,10 @@
           <a:solidFill>
             <a:srgbClr val="161638"/>
           </a:solidFill>
-          <a:ln>
-            <a:noFill/>
+          <a:ln w="6350">
+            <a:solidFill>
+              <a:srgbClr val="D0D7E8"/>
+            </a:solidFill>
           </a:ln>
         </p:spPr>
         <p:style>
@@ -14422,7 +14474,7 @@
             <a:srgbClr val="F39C12"/>
           </a:solidFill>
           <a:ln>
-            <a:noFill/>
+            <a:solidFill/>
           </a:ln>
         </p:spPr>
         <p:style>
@@ -14612,7 +14664,7 @@
     <p:bg>
       <p:bgPr>
         <a:solidFill>
-          <a:srgbClr val="F0F4FF"/>
+          <a:srgbClr val="0D0D1A"/>
         </a:solidFill>
         <a:effectLst/>
       </p:bgPr>
@@ -14658,7 +14710,7 @@
             <a:r>
               <a:rPr lang="en-US" sz="2800" b="1" dirty="0">
                 <a:solidFill>
-                  <a:srgbClr val="1A1A2E"/>
+                  <a:srgbClr val="FFFFFF"/>
                 </a:solidFill>
                 <a:latin typeface="Arial Black" pitchFamily="34" charset="0"/>
                 <a:ea typeface="Arial Black" pitchFamily="34" charset="-122"/>
@@ -14685,7 +14737,7 @@
             <a:avLst/>
           </a:prstGeom>
           <a:solidFill>
-            <a:srgbClr val="FFFFFF"/>
+            <a:srgbClr val="161638"/>
           </a:solidFill>
           <a:ln w="6350">
             <a:solidFill>
@@ -14718,7 +14770,7 @@
         <p:spPr>
           <a:xfrm>
             <a:off x="365760" y="1097280"/>
-            <a:ext cx="73152" cy="1554480"/>
+            <a:ext cx="64008" cy="1554480"/>
           </a:xfrm>
           <a:prstGeom prst="rect">
             <a:avLst/>
@@ -14768,7 +14820,7 @@
             <a:r>
               <a:rPr lang="en-US" sz="1500" b="1" dirty="0">
                 <a:solidFill>
-                  <a:srgbClr val="1A1A2E"/>
+                  <a:srgbClr val="FFFFFF"/>
                 </a:solidFill>
                 <a:latin typeface="Calibri" pitchFamily="34" charset="0"/>
                 <a:ea typeface="Calibri" pitchFamily="34" charset="-122"/>
@@ -14807,7 +14859,7 @@
             <a:r>
               <a:rPr lang="en-US" sz="1200" dirty="0">
                 <a:solidFill>
-                  <a:srgbClr val="444444"/>
+                  <a:srgbClr val="D0D7E8"/>
                 </a:solidFill>
                 <a:latin typeface="Calibri" pitchFamily="34" charset="0"/>
                 <a:ea typeface="Calibri" pitchFamily="34" charset="-122"/>
@@ -14824,7 +14876,7 @@
             <a:r>
               <a:rPr lang="en-US" sz="1200" dirty="0">
                 <a:solidFill>
-                  <a:srgbClr val="444444"/>
+                  <a:srgbClr val="D0D7E8"/>
                 </a:solidFill>
                 <a:latin typeface="Calibri" pitchFamily="34" charset="0"/>
                 <a:ea typeface="Calibri" pitchFamily="34" charset="-122"/>
@@ -14851,7 +14903,7 @@
             <a:avLst/>
           </a:prstGeom>
           <a:solidFill>
-            <a:srgbClr val="FFFFFF"/>
+            <a:srgbClr val="161638"/>
           </a:solidFill>
           <a:ln w="6350">
             <a:solidFill>
@@ -14884,7 +14936,7 @@
         <p:spPr>
           <a:xfrm>
             <a:off x="4754880" y="1097280"/>
-            <a:ext cx="73152" cy="1554480"/>
+            <a:ext cx="64008" cy="1554480"/>
           </a:xfrm>
           <a:prstGeom prst="rect">
             <a:avLst/>
@@ -14934,7 +14986,7 @@
             <a:r>
               <a:rPr lang="en-US" sz="1500" b="1" dirty="0">
                 <a:solidFill>
-                  <a:srgbClr val="1A1A2E"/>
+                  <a:srgbClr val="FFFFFF"/>
                 </a:solidFill>
                 <a:latin typeface="Calibri" pitchFamily="34" charset="0"/>
                 <a:ea typeface="Calibri" pitchFamily="34" charset="-122"/>
@@ -14973,7 +15025,7 @@
             <a:r>
               <a:rPr lang="en-US" sz="1200" dirty="0">
                 <a:solidFill>
-                  <a:srgbClr val="444444"/>
+                  <a:srgbClr val="D0D7E8"/>
                 </a:solidFill>
                 <a:latin typeface="Calibri" pitchFamily="34" charset="0"/>
                 <a:ea typeface="Calibri" pitchFamily="34" charset="-122"/>
@@ -15000,7 +15052,7 @@
             <a:avLst/>
           </a:prstGeom>
           <a:solidFill>
-            <a:srgbClr val="FFFFFF"/>
+            <a:srgbClr val="161638"/>
           </a:solidFill>
           <a:ln w="6350">
             <a:solidFill>
@@ -15033,7 +15085,7 @@
         <p:spPr>
           <a:xfrm>
             <a:off x="365760" y="2834640"/>
-            <a:ext cx="73152" cy="1554480"/>
+            <a:ext cx="64008" cy="1554480"/>
           </a:xfrm>
           <a:prstGeom prst="rect">
             <a:avLst/>
@@ -15083,7 +15135,7 @@
             <a:r>
               <a:rPr lang="en-US" sz="1500" b="1" dirty="0">
                 <a:solidFill>
-                  <a:srgbClr val="1A1A2E"/>
+                  <a:srgbClr val="FFFFFF"/>
                 </a:solidFill>
                 <a:latin typeface="Calibri" pitchFamily="34" charset="0"/>
                 <a:ea typeface="Calibri" pitchFamily="34" charset="-122"/>
@@ -15122,7 +15174,7 @@
             <a:r>
               <a:rPr lang="en-US" sz="1200" dirty="0">
                 <a:solidFill>
-                  <a:srgbClr val="444444"/>
+                  <a:srgbClr val="D0D7E8"/>
                 </a:solidFill>
                 <a:latin typeface="Calibri" pitchFamily="34" charset="0"/>
                 <a:ea typeface="Calibri" pitchFamily="34" charset="-122"/>
@@ -15149,7 +15201,7 @@
             <a:avLst/>
           </a:prstGeom>
           <a:solidFill>
-            <a:srgbClr val="FFFFFF"/>
+            <a:srgbClr val="161638"/>
           </a:solidFill>
           <a:ln w="6350">
             <a:solidFill>
@@ -15182,7 +15234,7 @@
         <p:spPr>
           <a:xfrm>
             <a:off x="4754880" y="2834640"/>
-            <a:ext cx="73152" cy="1554480"/>
+            <a:ext cx="64008" cy="1554480"/>
           </a:xfrm>
           <a:prstGeom prst="rect">
             <a:avLst/>
@@ -15232,7 +15284,7 @@
             <a:r>
               <a:rPr lang="en-US" sz="1500" b="1" dirty="0">
                 <a:solidFill>
-                  <a:srgbClr val="1A1A2E"/>
+                  <a:srgbClr val="FFFFFF"/>
                 </a:solidFill>
                 <a:latin typeface="Calibri" pitchFamily="34" charset="0"/>
                 <a:ea typeface="Calibri" pitchFamily="34" charset="-122"/>
@@ -15271,7 +15323,7 @@
             <a:r>
               <a:rPr lang="en-US" sz="1200" dirty="0">
                 <a:solidFill>
-                  <a:srgbClr val="444444"/>
+                  <a:srgbClr val="D0D7E8"/>
                 </a:solidFill>
                 <a:latin typeface="Calibri" pitchFamily="34" charset="0"/>
                 <a:ea typeface="Calibri" pitchFamily="34" charset="-122"/>
@@ -15313,6 +15365,9 @@
           <a:p>
             <a:r>
               <a:rPr lang="en-US" sz="800" dirty="0">
+                <a:solidFill>
+                  <a:srgbClr val="FFFFFF"/>
+                </a:solidFill>
                 <a:latin typeface="Calibri" pitchFamily="34" charset="0"/>
                 <a:ea typeface="Calibri" pitchFamily="34" charset="-122"/>
                 <a:cs typeface="Calibri" pitchFamily="34" charset="-120"/>
@@ -15416,7 +15471,7 @@
             <a:r>
               <a:rPr sz="800" b="1">
                 <a:solidFill>
-                  <a:srgbClr val="E94560"/>
+                  <a:srgbClr val="FFFFFF"/>
                 </a:solidFill>
               </a:rPr>
               <a:t>20</a:t>
@@ -15441,8 +15496,10 @@
           <a:solidFill>
             <a:srgbClr val="161638"/>
           </a:solidFill>
-          <a:ln>
-            <a:noFill/>
+          <a:ln w="6350">
+            <a:solidFill>
+              <a:srgbClr val="D0D7E8"/>
+            </a:solidFill>
           </a:ln>
         </p:spPr>
         <p:style>
@@ -15486,7 +15543,7 @@
             <a:srgbClr val="4472C4"/>
           </a:solidFill>
           <a:ln>
-            <a:noFill/>
+            <a:solidFill/>
           </a:ln>
         </p:spPr>
         <p:style>
@@ -15608,8 +15665,10 @@
           <a:solidFill>
             <a:srgbClr val="161638"/>
           </a:solidFill>
-          <a:ln>
-            <a:noFill/>
+          <a:ln w="6350">
+            <a:solidFill>
+              <a:srgbClr val="D0D7E8"/>
+            </a:solidFill>
           </a:ln>
         </p:spPr>
         <p:style>
@@ -15653,7 +15712,7 @@
             <a:srgbClr val="F39C12"/>
           </a:solidFill>
           <a:ln>
-            <a:noFill/>
+            <a:solidFill/>
           </a:ln>
         </p:spPr>
         <p:style>
@@ -15775,8 +15834,10 @@
           <a:solidFill>
             <a:srgbClr val="161638"/>
           </a:solidFill>
-          <a:ln>
-            <a:noFill/>
+          <a:ln w="6350">
+            <a:solidFill>
+              <a:srgbClr val="D0D7E8"/>
+            </a:solidFill>
           </a:ln>
         </p:spPr>
         <p:style>
@@ -15820,7 +15881,7 @@
             <a:srgbClr val="2ECC71"/>
           </a:solidFill>
           <a:ln>
-            <a:noFill/>
+            <a:solidFill/>
           </a:ln>
         </p:spPr>
         <p:style>
@@ -15975,8 +16036,10 @@
           <a:solidFill>
             <a:srgbClr val="161638"/>
           </a:solidFill>
-          <a:ln>
-            <a:noFill/>
+          <a:ln w="6350">
+            <a:solidFill>
+              <a:srgbClr val="D0D7E8"/>
+            </a:solidFill>
           </a:ln>
         </p:spPr>
         <p:style>
@@ -16020,7 +16083,7 @@
             <a:srgbClr val="9B59B6"/>
           </a:solidFill>
           <a:ln>
-            <a:noFill/>
+            <a:solidFill/>
           </a:ln>
         </p:spPr>
         <p:style>
@@ -16164,8 +16227,10 @@
           <a:solidFill>
             <a:srgbClr val="161638"/>
           </a:solidFill>
-          <a:ln>
-            <a:noFill/>
+          <a:ln w="6350">
+            <a:solidFill>
+              <a:srgbClr val="D0D7E8"/>
+            </a:solidFill>
           </a:ln>
         </p:spPr>
         <p:style>
@@ -16209,7 +16274,7 @@
             <a:srgbClr val="8A92A4"/>
           </a:solidFill>
           <a:ln>
-            <a:noFill/>
+            <a:solidFill/>
           </a:ln>
         </p:spPr>
         <p:style>
@@ -16407,7 +16472,7 @@
             <a:r>
               <a:rPr sz="800" b="1">
                 <a:solidFill>
-                  <a:srgbClr val="E94560"/>
+                  <a:srgbClr val="FFFFFF"/>
                 </a:solidFill>
               </a:rPr>
               <a:t>21</a:t>
@@ -16432,8 +16497,10 @@
           <a:solidFill>
             <a:srgbClr val="161638"/>
           </a:solidFill>
-          <a:ln>
-            <a:noFill/>
+          <a:ln w="6350">
+            <a:solidFill>
+              <a:srgbClr val="D0D7E8"/>
+            </a:solidFill>
           </a:ln>
         </p:spPr>
         <p:style>
@@ -16477,7 +16544,7 @@
             <a:srgbClr val="9B59B6"/>
           </a:solidFill>
           <a:ln>
-            <a:noFill/>
+            <a:solidFill/>
           </a:ln>
         </p:spPr>
         <p:style>
@@ -16790,8 +16857,10 @@
           <a:solidFill>
             <a:srgbClr val="161638"/>
           </a:solidFill>
-          <a:ln>
-            <a:noFill/>
+          <a:ln w="6350">
+            <a:solidFill>
+              <a:srgbClr val="D0D7E8"/>
+            </a:solidFill>
           </a:ln>
         </p:spPr>
         <p:style>
@@ -16835,7 +16904,7 @@
             <a:srgbClr val="2ECC71"/>
           </a:solidFill>
           <a:ln>
-            <a:noFill/>
+            <a:solidFill/>
           </a:ln>
         </p:spPr>
         <p:style>
@@ -17095,8 +17164,10 @@
           <a:solidFill>
             <a:srgbClr val="161638"/>
           </a:solidFill>
-          <a:ln>
-            <a:noFill/>
+          <a:ln w="6350">
+            <a:solidFill>
+              <a:srgbClr val="D0D7E8"/>
+            </a:solidFill>
           </a:ln>
         </p:spPr>
         <p:style>
@@ -17140,7 +17211,7 @@
             <a:srgbClr val="F39C12"/>
           </a:solidFill>
           <a:ln>
-            <a:noFill/>
+            <a:solidFill/>
           </a:ln>
         </p:spPr>
         <p:style>
@@ -17262,8 +17333,10 @@
           <a:solidFill>
             <a:srgbClr val="161638"/>
           </a:solidFill>
-          <a:ln>
-            <a:noFill/>
+          <a:ln w="6350">
+            <a:solidFill>
+              <a:srgbClr val="D0D7E8"/>
+            </a:solidFill>
           </a:ln>
         </p:spPr>
         <p:style>
@@ -17307,7 +17380,7 @@
             <a:srgbClr val="4472C4"/>
           </a:solidFill>
           <a:ln>
-            <a:noFill/>
+            <a:solidFill/>
           </a:ln>
         </p:spPr>
         <p:style>
@@ -17381,7 +17454,7 @@
         <p:spPr>
           <a:xfrm>
             <a:off x="515264" y="3104968"/>
-            <a:ext cx="3879800" cy="500000"/>
+            <a:ext cx="3879800" cy="600164"/>
           </a:xfrm>
           <a:prstGeom prst="rect">
             <a:avLst/>
@@ -17508,7 +17581,23 @@
                   <a:srgbClr val="D0D7E8"/>
                 </a:solidFill>
               </a:rPr>
-              <a:t>  ·  6 </a:t>
+              <a:t>  ·  </a:t>
+            </a:r>
+            <a:r>
+              <a:rPr lang="de-DE" sz="1100" b="0" dirty="0">
+                <a:solidFill>
+                  <a:srgbClr val="D0D7E8"/>
+                </a:solidFill>
+              </a:rPr>
+              <a:t>7</a:t>
+            </a:r>
+            <a:r>
+              <a:rPr sz="1100" b="0" dirty="0">
+                <a:solidFill>
+                  <a:srgbClr val="D0D7E8"/>
+                </a:solidFill>
+              </a:rPr>
+              <a:t> </a:t>
             </a:r>
             <a:r>
               <a:rPr sz="1100" b="0" dirty="0" err="1">
@@ -17543,8 +17632,10 @@
           <a:solidFill>
             <a:srgbClr val="161638"/>
           </a:solidFill>
-          <a:ln>
-            <a:noFill/>
+          <a:ln w="6350">
+            <a:solidFill>
+              <a:srgbClr val="D0D7E8"/>
+            </a:solidFill>
           </a:ln>
         </p:spPr>
         <p:style>
@@ -17588,7 +17679,7 @@
             <a:srgbClr val="8A92A4"/>
           </a:solidFill>
           <a:ln>
-            <a:noFill/>
+            <a:solidFill/>
           </a:ln>
         </p:spPr>
         <p:style>
@@ -17755,7 +17846,7 @@
             <a:srgbClr val="161638"/>
           </a:solidFill>
           <a:ln>
-            <a:noFill/>
+            <a:solidFill/>
           </a:ln>
         </p:spPr>
         <p:style>
@@ -17833,7 +17924,7 @@
             <a:srgbClr val="E94560"/>
           </a:solidFill>
           <a:ln>
-            <a:noFill/>
+            <a:solidFill/>
           </a:ln>
         </p:spPr>
         <p:style>
@@ -17936,7 +18027,7 @@
         <p:spPr>
           <a:xfrm>
             <a:off x="0" y="3150000"/>
-            <a:ext cx="9144000" cy="280000"/>
+            <a:ext cx="9144000" cy="292388"/>
           </a:xfrm>
           <a:prstGeom prst="rect">
             <a:avLst/>
@@ -17951,13 +18042,26 @@
           <a:p>
             <a:pPr algn="ctr"/>
             <a:r>
-              <a:rPr sz="1300" b="0">
+              <a:rPr sz="1300" b="0" dirty="0">
                 <a:solidFill>
                   <a:srgbClr val="8A92A4"/>
                 </a:solidFill>
               </a:rPr>
               <a:t>Lucas  ·  Jesse  ·  Uilliam  ·  Jakub  ·  Niklas  ·  Jamie</a:t>
             </a:r>
+            <a:r>
+              <a:rPr lang="de-DE" sz="1300" dirty="0">
+                <a:solidFill>
+                  <a:srgbClr val="8A92A4"/>
+                </a:solidFill>
+              </a:rPr>
+              <a:t> ·  Arda</a:t>
+            </a:r>
+            <a:endParaRPr sz="1300" b="0" dirty="0">
+              <a:solidFill>
+                <a:srgbClr val="8A92A4"/>
+              </a:solidFill>
+            </a:endParaRPr>
           </a:p>
         </p:txBody>
       </p:sp>
@@ -18012,8 +18116,10 @@
           <a:solidFill>
             <a:srgbClr val="161638"/>
           </a:solidFill>
-          <a:ln>
-            <a:noFill/>
+          <a:ln w="6350">
+            <a:solidFill>
+              <a:srgbClr val="D0D7E8"/>
+            </a:solidFill>
           </a:ln>
         </p:spPr>
         <p:style>
@@ -18232,7 +18338,7 @@
           </a:solidFill>
           <a:ln w="6350">
             <a:solidFill>
-              <a:srgbClr val="2A3A5E"/>
+              <a:srgbClr val="D0D7E8"/>
             </a:solidFill>
             <a:prstDash val="solid"/>
           </a:ln>
@@ -18374,7 +18480,7 @@
           </a:solidFill>
           <a:ln w="6350">
             <a:solidFill>
-              <a:srgbClr val="2A3A5E"/>
+              <a:srgbClr val="D0D7E8"/>
             </a:solidFill>
             <a:prstDash val="solid"/>
           </a:ln>
@@ -18516,7 +18622,7 @@
           </a:solidFill>
           <a:ln w="6350">
             <a:solidFill>
-              <a:srgbClr val="2A3A5E"/>
+              <a:srgbClr val="D0D7E8"/>
             </a:solidFill>
             <a:prstDash val="solid"/>
           </a:ln>
@@ -18658,7 +18764,7 @@
           </a:solidFill>
           <a:ln w="6350">
             <a:solidFill>
-              <a:srgbClr val="2A3A5E"/>
+              <a:srgbClr val="D0D7E8"/>
             </a:solidFill>
             <a:prstDash val="solid"/>
           </a:ln>
@@ -18800,7 +18906,7 @@
           </a:solidFill>
           <a:ln w="6350">
             <a:solidFill>
-              <a:srgbClr val="2A3A5E"/>
+              <a:srgbClr val="D0D7E8"/>
             </a:solidFill>
             <a:prstDash val="solid"/>
           </a:ln>
@@ -18942,7 +19048,7 @@
           </a:solidFill>
           <a:ln w="6350">
             <a:solidFill>
-              <a:srgbClr val="2A3A5E"/>
+              <a:srgbClr val="D0D7E8"/>
             </a:solidFill>
             <a:prstDash val="solid"/>
           </a:ln>
@@ -19084,7 +19190,7 @@
           </a:solidFill>
           <a:ln w="6350">
             <a:solidFill>
-              <a:srgbClr val="2A3A5E"/>
+              <a:srgbClr val="D0D7E8"/>
             </a:solidFill>
             <a:prstDash val="solid"/>
           </a:ln>
@@ -19226,7 +19332,7 @@
           </a:solidFill>
           <a:ln w="6350">
             <a:solidFill>
-              <a:srgbClr val="2A3A5E"/>
+              <a:srgbClr val="D0D7E8"/>
             </a:solidFill>
             <a:prstDash val="solid"/>
           </a:ln>
@@ -19380,7 +19486,7 @@
             <a:r>
               <a:rPr lang="en-US" sz="800" dirty="0">
                 <a:solidFill>
-                  <a:srgbClr val="E94560"/>
+                  <a:srgbClr val="FFFFFF"/>
                 </a:solidFill>
                 <a:latin typeface="Calibri" pitchFamily="34" charset="0"/>
                 <a:ea typeface="Calibri" pitchFamily="34" charset="-122"/>
@@ -19401,1003 +19507,6 @@
 </file>
 
 <file path=ppt/slides/slide4.xml><?xml version="1.0" encoding="utf-8"?>
-<p:sld xmlns:a="http://schemas.openxmlformats.org/drawingml/2006/main" xmlns:r="http://schemas.openxmlformats.org/officeDocument/2006/relationships" xmlns:p="http://schemas.openxmlformats.org/presentationml/2006/main">
-  <p:cSld>
-    <p:bg>
-      <p:bgPr>
-        <a:solidFill>
-          <a:srgbClr val="F0F4FF"/>
-        </a:solidFill>
-        <a:effectLst/>
-      </p:bgPr>
-    </p:bg>
-    <p:spTree>
-      <p:nvGrpSpPr>
-        <p:cNvPr id="1" name=""/>
-        <p:cNvGrpSpPr/>
-        <p:nvPr/>
-      </p:nvGrpSpPr>
-      <p:grpSpPr>
-        <a:xfrm>
-          <a:off x="0" y="0"/>
-          <a:ext cx="0" cy="0"/>
-          <a:chOff x="0" y="0"/>
-          <a:chExt cx="0" cy="0"/>
-        </a:xfrm>
-      </p:grpSpPr>
-      <p:sp>
-        <p:nvSpPr>
-          <p:cNvPr id="2" name="AccentStripe"/>
-          <p:cNvSpPr/>
-          <p:nvPr/>
-        </p:nvSpPr>
-        <p:spPr>
-          <a:xfrm>
-            <a:off x="0" y="0"/>
-            <a:ext cx="91440" cy="5143500"/>
-          </a:xfrm>
-          <a:prstGeom prst="rect">
-            <a:avLst/>
-          </a:prstGeom>
-          <a:solidFill>
-            <a:srgbClr val="4472C4"/>
-          </a:solidFill>
-        </p:spPr>
-        <p:txBody>
-          <a:bodyPr/>
-          <a:lstStyle/>
-          <a:p>
-            <a:endParaRPr lang="de-DE"/>
-          </a:p>
-        </p:txBody>
-      </p:sp>
-      <p:sp>
-        <p:nvSpPr>
-          <p:cNvPr id="3" name="Title"/>
-          <p:cNvSpPr/>
-          <p:nvPr/>
-        </p:nvSpPr>
-        <p:spPr>
-          <a:xfrm>
-            <a:off x="457200" y="256032"/>
-            <a:ext cx="8229600" cy="594360"/>
-          </a:xfrm>
-          <a:prstGeom prst="rect">
-            <a:avLst/>
-          </a:prstGeom>
-          <a:noFill/>
-          <a:ln/>
-        </p:spPr>
-        <p:txBody>
-          <a:bodyPr wrap="square" lIns="114300" tIns="91440" rIns="114300" bIns="91440" rtlCol="0" anchor="ctr"/>
-          <a:lstStyle/>
-          <a:p>
-            <a:pPr marL="0" indent="0" algn="l">
-              <a:buNone/>
-            </a:pPr>
-            <a:r>
-              <a:rPr lang="de-DE" sz="2800" b="1" dirty="0">
-                <a:solidFill>
-                  <a:srgbClr val="1A1A2E"/>
-                </a:solidFill>
-                <a:latin typeface="Arial Black" pitchFamily="49" charset="0"/>
-              </a:rPr>
-              <a:t>database.py – Flexible Datenbankzugriffe</a:t>
-            </a:r>
-          </a:p>
-        </p:txBody>
-      </p:sp>
-      <p:sp>
-        <p:nvSpPr>
-          <p:cNvPr id="4" name="Subtitle"/>
-          <p:cNvSpPr/>
-          <p:nvPr/>
-        </p:nvSpPr>
-        <p:spPr>
-          <a:xfrm>
-            <a:off x="457200" y="804672"/>
-            <a:ext cx="8229600" cy="320040"/>
-          </a:xfrm>
-          <a:prstGeom prst="rect">
-            <a:avLst/>
-          </a:prstGeom>
-          <a:noFill/>
-          <a:ln/>
-        </p:spPr>
-        <p:txBody>
-          <a:bodyPr wrap="square" lIns="114300" tIns="91440" rIns="114300" bIns="91440" rtlCol="0" anchor="ctr"/>
-          <a:lstStyle/>
-          <a:p>
-            <a:pPr marL="0" indent="0" algn="l">
-              <a:buNone/>
-            </a:pPr>
-            <a:r>
-              <a:rPr lang="de-DE" sz="1200" dirty="0">
-                <a:solidFill>
-                  <a:srgbClr val="8892A4"/>
-                </a:solidFill>
-                <a:latin typeface="Calibri" pitchFamily="49" charset="0"/>
-              </a:rPr>
-              <a:t>row_factory · Schema-Migration · SQL-Injection-Schutz</a:t>
-            </a:r>
-          </a:p>
-        </p:txBody>
-      </p:sp>
-      <p:sp>
-        <p:nvSpPr>
-          <p:cNvPr id="5" name="CodeCard"/>
-          <p:cNvSpPr/>
-          <p:nvPr/>
-        </p:nvSpPr>
-        <p:spPr>
-          <a:xfrm>
-            <a:off x="365760" y="1234440"/>
-            <a:ext cx="5250000" cy="3650000"/>
-          </a:xfrm>
-          <a:prstGeom prst="rect">
-            <a:avLst/>
-          </a:prstGeom>
-          <a:solidFill>
-            <a:srgbClr val="121224"/>
-          </a:solidFill>
-          <a:ln w="9525">
-            <a:solidFill>
-              <a:srgbClr val="4472C4"/>
-            </a:solidFill>
-            <a:prstDash val="solid"/>
-          </a:ln>
-        </p:spPr>
-        <p:txBody>
-          <a:bodyPr/>
-          <a:lstStyle/>
-          <a:p>
-            <a:endParaRPr lang="de-DE"/>
-          </a:p>
-        </p:txBody>
-      </p:sp>
-      <p:sp>
-        <p:nvSpPr>
-          <p:cNvPr id="6" name="CodeText"/>
-          <p:cNvSpPr/>
-          <p:nvPr/>
-        </p:nvSpPr>
-        <p:spPr>
-          <a:xfrm>
-            <a:off x="457200" y="1325880"/>
-            <a:ext cx="5067120" cy="3467120"/>
-          </a:xfrm>
-          <a:prstGeom prst="rect">
-            <a:avLst/>
-          </a:prstGeom>
-          <a:noFill/>
-          <a:ln/>
-        </p:spPr>
-        <p:txBody>
-          <a:bodyPr wrap="square" lIns="114300" tIns="91440" rIns="114300" bIns="91440" rtlCol="0" anchor="t"/>
-          <a:lstStyle/>
-          <a:p>
-            <a:pPr marL="0" indent="0" algn="l">
-              <a:buNone/>
-            </a:pPr>
-            <a:r>
-              <a:rPr lang="de-DE" sz="980" i="1" dirty="0">
-                <a:solidFill>
-                  <a:srgbClr val="5C6370"/>
-                </a:solidFill>
-                <a:latin typeface="Consolas" pitchFamily="49" charset="0"/>
-              </a:rPr>
-              <a:t># row_factory: Spaltenzugriff per Name statt Index</a:t>
-            </a:r>
-          </a:p>
-          <a:p>
-            <a:pPr marL="0" indent="0" algn="l">
-              <a:buNone/>
-            </a:pPr>
-            <a:r>
-              <a:rPr lang="de-DE" sz="980" dirty="0">
-                <a:solidFill>
-                  <a:srgbClr val="56B6C2"/>
-                </a:solidFill>
-                <a:latin typeface="Consolas" pitchFamily="49" charset="0"/>
-              </a:rPr>
-              <a:t>conn</a:t>
-            </a:r>
-            <a:r>
-              <a:rPr lang="de-DE" sz="980" dirty="0">
-                <a:solidFill>
-                  <a:srgbClr val="ABB2BF"/>
-                </a:solidFill>
-                <a:latin typeface="Consolas" pitchFamily="49" charset="0"/>
-              </a:rPr>
-              <a:t>.row_factory = </a:t>
-            </a:r>
-            <a:r>
-              <a:rPr lang="de-DE" sz="980" dirty="0">
-                <a:solidFill>
-                  <a:srgbClr val="61AFEF"/>
-                </a:solidFill>
-                <a:latin typeface="Consolas" pitchFamily="49" charset="0"/>
-              </a:rPr>
-              <a:t>sqlite3</a:t>
-            </a:r>
-            <a:r>
-              <a:rPr lang="de-DE" sz="980" dirty="0">
-                <a:solidFill>
-                  <a:srgbClr val="ABB2BF"/>
-                </a:solidFill>
-                <a:latin typeface="Consolas" pitchFamily="49" charset="0"/>
-              </a:rPr>
-              <a:t>.Row</a:t>
-            </a:r>
-          </a:p>
-          <a:p>
-            <a:pPr marL="0" indent="0" algn="l">
-              <a:buNone/>
-            </a:pPr>
-            <a:r>
-              <a:rPr lang="de-DE" sz="980" dirty="0">
-                <a:solidFill>
-                  <a:srgbClr val="56B6C2"/>
-                </a:solidFill>
-                <a:latin typeface="Consolas" pitchFamily="49" charset="0"/>
-              </a:rPr>
-              <a:t>row</a:t>
-            </a:r>
-            <a:r>
-              <a:rPr lang="de-DE" sz="980" dirty="0">
-                <a:solidFill>
-                  <a:srgbClr val="ABB2BF"/>
-                </a:solidFill>
-                <a:latin typeface="Consolas" pitchFamily="49" charset="0"/>
-              </a:rPr>
-              <a:t> = cursor.</a:t>
-            </a:r>
-            <a:r>
-              <a:rPr lang="de-DE" sz="980" dirty="0">
-                <a:solidFill>
-                  <a:srgbClr val="61AFEF"/>
-                </a:solidFill>
-                <a:latin typeface="Consolas" pitchFamily="49" charset="0"/>
-              </a:rPr>
-              <a:t>fetchone</a:t>
-            </a:r>
-            <a:r>
-              <a:rPr lang="de-DE" sz="980" dirty="0">
-                <a:solidFill>
-                  <a:srgbClr val="ABB2BF"/>
-                </a:solidFill>
-                <a:latin typeface="Consolas" pitchFamily="49" charset="0"/>
-              </a:rPr>
-              <a:t>()</a:t>
-            </a:r>
-          </a:p>
-          <a:p>
-            <a:pPr marL="0" indent="0" algn="l">
-              <a:buNone/>
-            </a:pPr>
-            <a:r>
-              <a:rPr lang="de-DE" sz="980" dirty="0">
-                <a:solidFill>
-                  <a:srgbClr val="56B6C2"/>
-                </a:solidFill>
-                <a:latin typeface="Consolas" pitchFamily="49" charset="0"/>
-              </a:rPr>
-              <a:t>print</a:t>
-            </a:r>
-            <a:r>
-              <a:rPr lang="de-DE" sz="980" dirty="0">
-                <a:solidFill>
-                  <a:srgbClr val="ABB2BF"/>
-                </a:solidFill>
-                <a:latin typeface="Consolas" pitchFamily="49" charset="0"/>
-              </a:rPr>
-              <a:t>(row[</a:t>
-            </a:r>
-            <a:r>
-              <a:rPr lang="de-DE" sz="980" dirty="0">
-                <a:solidFill>
-                  <a:srgbClr val="98C379"/>
-                </a:solidFill>
-                <a:latin typeface="Consolas" pitchFamily="49" charset="0"/>
-              </a:rPr>
-              <a:t>"username"</a:t>
-            </a:r>
-            <a:r>
-              <a:rPr lang="de-DE" sz="980" dirty="0">
-                <a:solidFill>
-                  <a:srgbClr val="ABB2BF"/>
-                </a:solidFill>
-                <a:latin typeface="Consolas" pitchFamily="49" charset="0"/>
-              </a:rPr>
-              <a:t>])  </a:t>
-            </a:r>
-            <a:r>
-              <a:rPr lang="de-DE" sz="980" i="1" dirty="0">
-                <a:solidFill>
-                  <a:srgbClr val="5C6370"/>
-                </a:solidFill>
-                <a:latin typeface="Consolas" pitchFamily="49" charset="0"/>
-              </a:rPr>
-              <a:t># statt row[1]</a:t>
-            </a:r>
-          </a:p>
-          <a:p>
-            <a:pPr marL="0" indent="0" algn="l">
-              <a:buNone/>
-            </a:pPr>
-            <a:r>
-              <a:rPr lang="de-DE" sz="980" dirty="0">
-                <a:solidFill>
-                  <a:srgbClr val="56B6C2"/>
-                </a:solidFill>
-                <a:latin typeface="Consolas" pitchFamily="49" charset="0"/>
-              </a:rPr>
-              <a:t>return</a:t>
-            </a:r>
-            <a:r>
-              <a:rPr lang="de-DE" sz="980" dirty="0">
-                <a:solidFill>
-                  <a:srgbClr val="ABB2BF"/>
-                </a:solidFill>
-                <a:latin typeface="Consolas" pitchFamily="49" charset="0"/>
-              </a:rPr>
-              <a:t> </a:t>
-            </a:r>
-            <a:r>
-              <a:rPr lang="de-DE" sz="980" dirty="0">
-                <a:solidFill>
-                  <a:srgbClr val="61AFEF"/>
-                </a:solidFill>
-                <a:latin typeface="Consolas" pitchFamily="49" charset="0"/>
-              </a:rPr>
-              <a:t>dict</a:t>
-            </a:r>
-            <a:r>
-              <a:rPr lang="de-DE" sz="980" dirty="0">
-                <a:solidFill>
-                  <a:srgbClr val="ABB2BF"/>
-                </a:solidFill>
-                <a:latin typeface="Consolas" pitchFamily="49" charset="0"/>
-              </a:rPr>
-              <a:t>(row)      </a:t>
-            </a:r>
-            <a:r>
-              <a:rPr lang="de-DE" sz="980" i="1" dirty="0">
-                <a:solidFill>
-                  <a:srgbClr val="5C6370"/>
-                </a:solidFill>
-                <a:latin typeface="Consolas" pitchFamily="49" charset="0"/>
-              </a:rPr>
-              <a:t># einfache Serialisierung</a:t>
-            </a:r>
-          </a:p>
-          <a:p>
-            <a:pPr>
-              <a:buNone/>
-            </a:pPr>
-            <a:endParaRPr lang="de-DE" sz="600" dirty="0"/>
-          </a:p>
-          <a:p>
-            <a:pPr marL="0" indent="0" algn="l">
-              <a:buNone/>
-            </a:pPr>
-            <a:r>
-              <a:rPr lang="de-DE" sz="980" i="1" dirty="0">
-                <a:solidFill>
-                  <a:srgbClr val="5C6370"/>
-                </a:solidFill>
-                <a:latin typeface="Consolas" pitchFamily="49" charset="0"/>
-              </a:rPr>
-              <a:t># Schema-Migration: neue Spalte nachrüsten</a:t>
-            </a:r>
-          </a:p>
-          <a:p>
-            <a:pPr marL="0" indent="0" algn="l">
-              <a:buNone/>
-            </a:pPr>
-            <a:r>
-              <a:rPr lang="de-DE" sz="980" dirty="0">
-                <a:solidFill>
-                  <a:srgbClr val="56B6C2"/>
-                </a:solidFill>
-                <a:latin typeface="Consolas" pitchFamily="49" charset="0"/>
-              </a:rPr>
-              <a:t>try</a:t>
-            </a:r>
-            <a:r>
-              <a:rPr lang="de-DE" sz="980" dirty="0">
-                <a:solidFill>
-                  <a:srgbClr val="ABB2BF"/>
-                </a:solidFill>
-                <a:latin typeface="Consolas" pitchFamily="49" charset="0"/>
-              </a:rPr>
-              <a:t>:</a:t>
-            </a:r>
-          </a:p>
-          <a:p>
-            <a:pPr marL="0" indent="0" algn="l">
-              <a:buNone/>
-            </a:pPr>
-            <a:r>
-              <a:rPr lang="de-DE" sz="980" dirty="0">
-                <a:solidFill>
-                  <a:srgbClr val="ABB2BF"/>
-                </a:solidFill>
-                <a:latin typeface="Consolas" pitchFamily="49" charset="0"/>
-              </a:rPr>
-              <a:t>    cursor.</a:t>
-            </a:r>
-            <a:r>
-              <a:rPr lang="de-DE" sz="980" dirty="0">
-                <a:solidFill>
-                  <a:srgbClr val="61AFEF"/>
-                </a:solidFill>
-                <a:latin typeface="Consolas" pitchFamily="49" charset="0"/>
-              </a:rPr>
-              <a:t>execute</a:t>
-            </a:r>
-            <a:r>
-              <a:rPr lang="de-DE" sz="980" dirty="0">
-                <a:solidFill>
-                  <a:srgbClr val="ABB2BF"/>
-                </a:solidFill>
-                <a:latin typeface="Consolas" pitchFamily="49" charset="0"/>
-              </a:rPr>
-              <a:t>(</a:t>
-            </a:r>
-          </a:p>
-          <a:p>
-            <a:pPr marL="0" indent="0" algn="l">
-              <a:buNone/>
-            </a:pPr>
-            <a:r>
-              <a:rPr lang="de-DE" sz="980" dirty="0">
-                <a:solidFill>
-                  <a:srgbClr val="ABB2BF"/>
-                </a:solidFill>
-                <a:latin typeface="Consolas" pitchFamily="49" charset="0"/>
-              </a:rPr>
-              <a:t>        </a:t>
-            </a:r>
-            <a:r>
-              <a:rPr lang="de-DE" sz="980" dirty="0">
-                <a:solidFill>
-                  <a:srgbClr val="98C379"/>
-                </a:solidFill>
-                <a:latin typeface="Consolas" pitchFamily="49" charset="0"/>
-              </a:rPr>
-              <a:t>"ALTER TABLE users"</a:t>
-            </a:r>
-          </a:p>
-          <a:p>
-            <a:pPr marL="0" indent="0" algn="l">
-              <a:buNone/>
-            </a:pPr>
-            <a:r>
-              <a:rPr lang="de-DE" sz="980" dirty="0">
-                <a:solidFill>
-                  <a:srgbClr val="ABB2BF"/>
-                </a:solidFill>
-                <a:latin typeface="Consolas" pitchFamily="49" charset="0"/>
-              </a:rPr>
-              <a:t>        </a:t>
-            </a:r>
-            <a:r>
-              <a:rPr lang="de-DE" sz="980" dirty="0">
-                <a:solidFill>
-                  <a:srgbClr val="98C379"/>
-                </a:solidFill>
-                <a:latin typeface="Consolas" pitchFamily="49" charset="0"/>
-              </a:rPr>
-              <a:t>"ADD COLUMN language TEXT DEFAULT 'en'"</a:t>
-            </a:r>
-          </a:p>
-          <a:p>
-            <a:pPr marL="0" indent="0" algn="l">
-              <a:buNone/>
-            </a:pPr>
-            <a:r>
-              <a:rPr lang="de-DE" sz="980" dirty="0">
-                <a:solidFill>
-                  <a:srgbClr val="ABB2BF"/>
-                </a:solidFill>
-                <a:latin typeface="Consolas" pitchFamily="49" charset="0"/>
-              </a:rPr>
-              <a:t>    )</a:t>
-            </a:r>
-          </a:p>
-          <a:p>
-            <a:pPr marL="0" indent="0" algn="l">
-              <a:buNone/>
-            </a:pPr>
-            <a:r>
-              <a:rPr lang="de-DE" sz="980" dirty="0">
-                <a:solidFill>
-                  <a:srgbClr val="ABB2BF"/>
-                </a:solidFill>
-                <a:latin typeface="Consolas" pitchFamily="49" charset="0"/>
-              </a:rPr>
-              <a:t>    conn.</a:t>
-            </a:r>
-            <a:r>
-              <a:rPr lang="de-DE" sz="980" dirty="0">
-                <a:solidFill>
-                  <a:srgbClr val="61AFEF"/>
-                </a:solidFill>
-                <a:latin typeface="Consolas" pitchFamily="49" charset="0"/>
-              </a:rPr>
-              <a:t>commit</a:t>
-            </a:r>
-            <a:r>
-              <a:rPr lang="de-DE" sz="980" dirty="0">
-                <a:solidFill>
-                  <a:srgbClr val="ABB2BF"/>
-                </a:solidFill>
-                <a:latin typeface="Consolas" pitchFamily="49" charset="0"/>
-              </a:rPr>
-              <a:t>()</a:t>
-            </a:r>
-          </a:p>
-          <a:p>
-            <a:pPr marL="0" indent="0" algn="l">
-              <a:buNone/>
-            </a:pPr>
-            <a:r>
-              <a:rPr lang="de-DE" sz="980" dirty="0">
-                <a:solidFill>
-                  <a:srgbClr val="56B6C2"/>
-                </a:solidFill>
-                <a:latin typeface="Consolas" pitchFamily="49" charset="0"/>
-              </a:rPr>
-              <a:t>except</a:t>
-            </a:r>
-            <a:r>
-              <a:rPr lang="de-DE" sz="980" dirty="0">
-                <a:solidFill>
-                  <a:srgbClr val="ABB2BF"/>
-                </a:solidFill>
-                <a:latin typeface="Consolas" pitchFamily="49" charset="0"/>
-              </a:rPr>
-              <a:t> sqlite3.</a:t>
-            </a:r>
-            <a:r>
-              <a:rPr lang="de-DE" sz="980" dirty="0">
-                <a:solidFill>
-                  <a:srgbClr val="61AFEF"/>
-                </a:solidFill>
-                <a:latin typeface="Consolas" pitchFamily="49" charset="0"/>
-              </a:rPr>
-              <a:t>OperationalError</a:t>
-            </a:r>
-            <a:r>
-              <a:rPr lang="de-DE" sz="980" dirty="0">
-                <a:solidFill>
-                  <a:srgbClr val="ABB2BF"/>
-                </a:solidFill>
-                <a:latin typeface="Consolas" pitchFamily="49" charset="0"/>
-              </a:rPr>
-              <a:t>:</a:t>
-            </a:r>
-          </a:p>
-          <a:p>
-            <a:pPr marL="0" indent="0" algn="l">
-              <a:buNone/>
-            </a:pPr>
-            <a:r>
-              <a:rPr lang="de-DE" sz="980" dirty="0">
-                <a:solidFill>
-                  <a:srgbClr val="ABB2BF"/>
-                </a:solidFill>
-                <a:latin typeface="Consolas" pitchFamily="49" charset="0"/>
-              </a:rPr>
-              <a:t>    </a:t>
-            </a:r>
-            <a:r>
-              <a:rPr lang="de-DE" sz="980" dirty="0">
-                <a:solidFill>
-                  <a:srgbClr val="56B6C2"/>
-                </a:solidFill>
-                <a:latin typeface="Consolas" pitchFamily="49" charset="0"/>
-              </a:rPr>
-              <a:t>pass</a:t>
-            </a:r>
-            <a:r>
-              <a:rPr lang="de-DE" sz="980" dirty="0">
-                <a:solidFill>
-                  <a:srgbClr val="ABB2BF"/>
-                </a:solidFill>
-                <a:latin typeface="Consolas" pitchFamily="49" charset="0"/>
-              </a:rPr>
-              <a:t>  </a:t>
-            </a:r>
-            <a:r>
-              <a:rPr lang="de-DE" sz="980" i="1" dirty="0">
-                <a:solidFill>
-                  <a:srgbClr val="5C6370"/>
-                </a:solidFill>
-                <a:latin typeface="Consolas" pitchFamily="49" charset="0"/>
-              </a:rPr>
-              <a:t># Spalte existiert bereits</a:t>
-            </a:r>
-          </a:p>
-          <a:p>
-            <a:pPr>
-              <a:buNone/>
-            </a:pPr>
-            <a:endParaRPr lang="de-DE" sz="600" dirty="0"/>
-          </a:p>
-          <a:p>
-            <a:pPr marL="0" indent="0" algn="l">
-              <a:buNone/>
-            </a:pPr>
-            <a:r>
-              <a:rPr lang="de-DE" sz="980" i="1" dirty="0">
-                <a:solidFill>
-                  <a:srgbClr val="5C6370"/>
-                </a:solidFill>
-                <a:latin typeface="Consolas" pitchFamily="49" charset="0"/>
-              </a:rPr>
-              <a:t># SQL-Injection-Schutz: Parameterized Queries</a:t>
-            </a:r>
-          </a:p>
-          <a:p>
-            <a:pPr marL="0" indent="0" algn="l">
-              <a:buNone/>
-            </a:pPr>
-            <a:r>
-              <a:rPr lang="de-DE" sz="980" dirty="0">
-                <a:solidFill>
-                  <a:srgbClr val="ABB2BF"/>
-                </a:solidFill>
-                <a:latin typeface="Consolas" pitchFamily="49" charset="0"/>
-              </a:rPr>
-              <a:t>cursor.</a:t>
-            </a:r>
-            <a:r>
-              <a:rPr lang="de-DE" sz="980" dirty="0">
-                <a:solidFill>
-                  <a:srgbClr val="61AFEF"/>
-                </a:solidFill>
-                <a:latin typeface="Consolas" pitchFamily="49" charset="0"/>
-              </a:rPr>
-              <a:t>execute</a:t>
-            </a:r>
-            <a:r>
-              <a:rPr lang="de-DE" sz="980" dirty="0">
-                <a:solidFill>
-                  <a:srgbClr val="ABB2BF"/>
-                </a:solidFill>
-                <a:latin typeface="Consolas" pitchFamily="49" charset="0"/>
-              </a:rPr>
-              <a:t>(</a:t>
-            </a:r>
-          </a:p>
-          <a:p>
-            <a:pPr marL="0" indent="0" algn="l">
-              <a:buNone/>
-            </a:pPr>
-            <a:r>
-              <a:rPr lang="de-DE" sz="980" dirty="0">
-                <a:solidFill>
-                  <a:srgbClr val="ABB2BF"/>
-                </a:solidFill>
-                <a:latin typeface="Consolas" pitchFamily="49" charset="0"/>
-              </a:rPr>
-              <a:t>    </a:t>
-            </a:r>
-            <a:r>
-              <a:rPr lang="de-DE" sz="980" dirty="0">
-                <a:solidFill>
-                  <a:srgbClr val="98C379"/>
-                </a:solidFill>
-                <a:latin typeface="Consolas" pitchFamily="49" charset="0"/>
-              </a:rPr>
-              <a:t>"SELECT * FROM users WHERE username = ?"</a:t>
-            </a:r>
-            <a:r>
-              <a:rPr lang="de-DE" sz="980" dirty="0">
-                <a:solidFill>
-                  <a:srgbClr val="ABB2BF"/>
-                </a:solidFill>
-                <a:latin typeface="Consolas" pitchFamily="49" charset="0"/>
-              </a:rPr>
-              <a:t>,</a:t>
-            </a:r>
-          </a:p>
-          <a:p>
-            <a:pPr marL="0" indent="0" algn="l">
-              <a:buNone/>
-            </a:pPr>
-            <a:r>
-              <a:rPr lang="de-DE" sz="980" dirty="0">
-                <a:solidFill>
-                  <a:srgbClr val="ABB2BF"/>
-                </a:solidFill>
-                <a:latin typeface="Consolas" pitchFamily="49" charset="0"/>
-              </a:rPr>
-              <a:t>    (username,)  </a:t>
-            </a:r>
-            <a:r>
-              <a:rPr lang="de-DE" sz="980" i="1" dirty="0">
-                <a:solidFill>
-                  <a:srgbClr val="5C6370"/>
-                </a:solidFill>
-                <a:latin typeface="Consolas" pitchFamily="49" charset="0"/>
-              </a:rPr>
-              <a:t># ? wird sicher ersetzt</a:t>
-            </a:r>
-          </a:p>
-          <a:p>
-            <a:pPr marL="0" indent="0" algn="l">
-              <a:buNone/>
-            </a:pPr>
-            <a:r>
-              <a:rPr lang="de-DE" sz="980" dirty="0">
-                <a:solidFill>
-                  <a:srgbClr val="ABB2BF"/>
-                </a:solidFill>
-                <a:latin typeface="Consolas" pitchFamily="49" charset="0"/>
-              </a:rPr>
-              <a:t>)</a:t>
-            </a:r>
-          </a:p>
-        </p:txBody>
-      </p:sp>
-      <p:sp>
-        <p:nvSpPr>
-          <p:cNvPr id="7" name="BulletCard"/>
-          <p:cNvSpPr/>
-          <p:nvPr/>
-        </p:nvSpPr>
-        <p:spPr>
-          <a:xfrm>
-            <a:off x="5707200" y="1234440"/>
-            <a:ext cx="3071040" cy="3650000"/>
-          </a:xfrm>
-          <a:prstGeom prst="rect">
-            <a:avLst/>
-          </a:prstGeom>
-          <a:solidFill>
-            <a:srgbClr val="FFFFFF"/>
-          </a:solidFill>
-          <a:ln w="6350">
-            <a:solidFill>
-              <a:srgbClr val="D0D7E8"/>
-            </a:solidFill>
-            <a:prstDash val="solid"/>
-          </a:ln>
-        </p:spPr>
-        <p:txBody>
-          <a:bodyPr/>
-          <a:lstStyle/>
-          <a:p>
-            <a:endParaRPr lang="de-DE"/>
-          </a:p>
-        </p:txBody>
-      </p:sp>
-      <p:sp>
-        <p:nvSpPr>
-          <p:cNvPr id="8" name="BulletText"/>
-          <p:cNvSpPr/>
-          <p:nvPr/>
-        </p:nvSpPr>
-        <p:spPr>
-          <a:xfrm>
-            <a:off x="5798640" y="1325880"/>
-            <a:ext cx="2888160" cy="3467120"/>
-          </a:xfrm>
-          <a:prstGeom prst="rect">
-            <a:avLst/>
-          </a:prstGeom>
-          <a:noFill/>
-          <a:ln/>
-        </p:spPr>
-        <p:txBody>
-          <a:bodyPr wrap="square" lIns="114300" tIns="91440" rIns="114300" bIns="91440" rtlCol="0" anchor="t"/>
-          <a:lstStyle/>
-          <a:p>
-            <a:pPr marL="342900" indent="-342900" algn="l">
-              <a:buChar char="▸"/>
-            </a:pPr>
-            <a:r>
-              <a:rPr lang="de-DE" sz="1150" b="1" dirty="0">
-                <a:solidFill>
-                  <a:srgbClr val="2A3A5E"/>
-                </a:solidFill>
-                <a:latin typeface="Calibri" pitchFamily="49" charset="0"/>
-              </a:rPr>
-              <a:t>sqlite3.Row</a:t>
-            </a:r>
-          </a:p>
-          <a:p>
-            <a:pPr marL="342900" indent="0" algn="l">
-              <a:buNone/>
-            </a:pPr>
-            <a:r>
-              <a:rPr lang="de-DE" sz="1000" dirty="0">
-                <a:solidFill>
-                  <a:srgbClr val="8892A4"/>
-                </a:solidFill>
-                <a:latin typeface="Calibri" pitchFamily="49" charset="0"/>
-              </a:rPr>
-              <a:t>Spaltenzugriff per Name: row["username"] statt row[1]</a:t>
-            </a:r>
-          </a:p>
-          <a:p>
-            <a:pPr marL="342900" indent="-342900" algn="l">
-              <a:spcBef>
-                <a:spcPts val="160"/>
-              </a:spcBef>
-              <a:buChar char="▸"/>
-            </a:pPr>
-            <a:r>
-              <a:rPr lang="de-DE" sz="1150" b="1" dirty="0">
-                <a:solidFill>
-                  <a:srgbClr val="2A3A5E"/>
-                </a:solidFill>
-                <a:latin typeface="Calibri" pitchFamily="49" charset="0"/>
-              </a:rPr>
-              <a:t>dict(row)</a:t>
-            </a:r>
-          </a:p>
-          <a:p>
-            <a:pPr marL="342900" indent="0" algn="l">
-              <a:buNone/>
-            </a:pPr>
-            <a:r>
-              <a:rPr lang="de-DE" sz="1000" dirty="0">
-                <a:solidFill>
-                  <a:srgbClr val="8892A4"/>
-                </a:solidFill>
-                <a:latin typeface="Calibri" pitchFamily="49" charset="0"/>
-              </a:rPr>
-              <a:t>Einfache Konvertierung für den Rest der App</a:t>
-            </a:r>
-          </a:p>
-          <a:p>
-            <a:pPr marL="342900" indent="-342900" algn="l">
-              <a:spcBef>
-                <a:spcPts val="160"/>
-              </a:spcBef>
-              <a:buChar char="▸"/>
-            </a:pPr>
-            <a:r>
-              <a:rPr lang="de-DE" sz="1150" b="1" dirty="0">
-                <a:solidFill>
-                  <a:srgbClr val="2A3A5E"/>
-                </a:solidFill>
-                <a:latin typeface="Calibri" pitchFamily="49" charset="0"/>
-              </a:rPr>
-              <a:t>try/except Migration</a:t>
-            </a:r>
-          </a:p>
-          <a:p>
-            <a:pPr marL="342900" indent="0" algn="l">
-              <a:buNone/>
-            </a:pPr>
-            <a:r>
-              <a:rPr lang="de-DE" sz="1000" dirty="0">
-                <a:solidFill>
-                  <a:srgbClr val="8892A4"/>
-                </a:solidFill>
-                <a:latin typeface="Calibri" pitchFamily="49" charset="0"/>
-              </a:rPr>
-              <a:t>DB bleibt kompatibel wenn Spalte schon existiert</a:t>
-            </a:r>
-          </a:p>
-          <a:p>
-            <a:pPr marL="342900" indent="-342900" algn="l">
-              <a:spcBef>
-                <a:spcPts val="160"/>
-              </a:spcBef>
-              <a:buChar char="▸"/>
-            </a:pPr>
-            <a:r>
-              <a:rPr lang="de-DE" sz="1150" b="1" dirty="0">
-                <a:solidFill>
-                  <a:srgbClr val="2A3A5E"/>
-                </a:solidFill>
-                <a:latin typeface="Calibri" pitchFamily="49" charset="0"/>
-              </a:rPr>
-              <a:t>?-Platzhalter</a:t>
-            </a:r>
-          </a:p>
-          <a:p>
-            <a:pPr marL="342900" indent="0" algn="l">
-              <a:buNone/>
-            </a:pPr>
-            <a:r>
-              <a:rPr lang="de-DE" sz="1000" dirty="0">
-                <a:solidFill>
-                  <a:srgbClr val="8892A4"/>
-                </a:solidFill>
-                <a:latin typeface="Calibri" pitchFamily="49" charset="0"/>
-              </a:rPr>
-              <a:t>Schutz vor SQL-Injection (OWASP Top 10)</a:t>
-            </a:r>
-          </a:p>
-          <a:p>
-            <a:pPr marL="342900" indent="-342900" algn="l">
-              <a:spcBef>
-                <a:spcPts val="160"/>
-              </a:spcBef>
-              <a:buChar char="▸"/>
-            </a:pPr>
-            <a:r>
-              <a:rPr lang="de-DE" sz="1150" b="1" dirty="0">
-                <a:solidFill>
-                  <a:srgbClr val="2A3A5E"/>
-                </a:solidFill>
-                <a:latin typeface="Calibri" pitchFamily="49" charset="0"/>
-              </a:rPr>
-              <a:t>IntegrityError</a:t>
-            </a:r>
-          </a:p>
-          <a:p>
-            <a:pPr marL="342900" indent="0" algn="l">
-              <a:buNone/>
-            </a:pPr>
-            <a:r>
-              <a:rPr lang="de-DE" sz="1000" dirty="0">
-                <a:solidFill>
-                  <a:srgbClr val="8892A4"/>
-                </a:solidFill>
-                <a:latin typeface="Calibri" pitchFamily="49" charset="0"/>
-              </a:rPr>
-              <a:t>Doppelte Benutzernamen werden sauber abgefangen</a:t>
-            </a:r>
-          </a:p>
-        </p:txBody>
-      </p:sp>
-      <p:sp>
-        <p:nvSpPr>
-          <p:cNvPr id="9" name="Textfeld 8">
-            <a:extLst>
-              <a:ext uri="{FF2B5EF4-FFF2-40B4-BE49-F238E27FC236}">
-                <a16:creationId xmlns:a16="http://schemas.microsoft.com/office/drawing/2014/main" id="{3FE34108-9161-8AE9-4D11-BFE9571AD1A5}"/>
-              </a:ext>
-            </a:extLst>
-          </p:cNvPr>
-          <p:cNvSpPr txBox="1"/>
-          <p:nvPr/>
-        </p:nvSpPr>
-        <p:spPr>
-          <a:xfrm>
-            <a:off x="8737093" y="4875028"/>
-            <a:ext cx="228600" cy="215444"/>
-          </a:xfrm>
-          <a:prstGeom prst="rect">
-            <a:avLst/>
-          </a:prstGeom>
-          <a:noFill/>
-        </p:spPr>
-        <p:txBody>
-          <a:bodyPr wrap="square" rtlCol="0">
-            <a:spAutoFit/>
-          </a:bodyPr>
-          <a:lstStyle/>
-          <a:p>
-            <a:r>
-              <a:rPr lang="en-US" sz="800" dirty="0">
-                <a:latin typeface="Calibri" pitchFamily="34" charset="0"/>
-                <a:ea typeface="Calibri" pitchFamily="34" charset="-122"/>
-                <a:cs typeface="Calibri" pitchFamily="34" charset="-120"/>
-              </a:rPr>
-              <a:t>4</a:t>
-            </a:r>
-            <a:endParaRPr lang="de-DE" sz="800" dirty="0"/>
-          </a:p>
-        </p:txBody>
-      </p:sp>
-    </p:spTree>
-  </p:cSld>
-  <p:clrMapOvr>
-    <a:masterClrMapping/>
-  </p:clrMapOvr>
-</p:sld>
-</file>
-
-<file path=ppt/slides/slide5.xml><?xml version="1.0" encoding="utf-8"?>
 <p:sld xmlns:a="http://schemas.openxmlformats.org/drawingml/2006/main" xmlns:r="http://schemas.openxmlformats.org/officeDocument/2006/relationships" xmlns:p="http://schemas.openxmlformats.org/presentationml/2006/main">
   <p:cSld name="Slide 7">
     <p:bg>
@@ -20480,7 +19589,7 @@
           </a:solidFill>
           <a:ln w="6350">
             <a:solidFill>
-              <a:srgbClr val="2A3A5E"/>
+              <a:srgbClr val="D0D7E8"/>
             </a:solidFill>
             <a:prstDash val="solid"/>
           </a:ln>
@@ -21051,7 +20160,7 @@
           </a:solidFill>
           <a:ln w="6350">
             <a:solidFill>
-              <a:srgbClr val="2A3A5E"/>
+              <a:srgbClr val="D0D7E8"/>
             </a:solidFill>
             <a:prstDash val="solid"/>
           </a:ln>
@@ -21673,7 +20782,1010 @@
             <a:r>
               <a:rPr lang="en-US" sz="800" dirty="0">
                 <a:solidFill>
-                  <a:srgbClr val="E94560"/>
+                  <a:srgbClr val="FFFFFF"/>
+                </a:solidFill>
+                <a:latin typeface="Calibri" pitchFamily="34" charset="0"/>
+                <a:ea typeface="Calibri" pitchFamily="34" charset="-122"/>
+                <a:cs typeface="Calibri" pitchFamily="34" charset="-120"/>
+              </a:rPr>
+              <a:t>4</a:t>
+            </a:r>
+            <a:endParaRPr lang="de-DE" sz="800" dirty="0"/>
+          </a:p>
+        </p:txBody>
+      </p:sp>
+    </p:spTree>
+  </p:cSld>
+  <p:clrMapOvr>
+    <a:masterClrMapping/>
+  </p:clrMapOvr>
+</p:sld>
+</file>
+
+<file path=ppt/slides/slide5.xml><?xml version="1.0" encoding="utf-8"?>
+<p:sld xmlns:a="http://schemas.openxmlformats.org/drawingml/2006/main" xmlns:r="http://schemas.openxmlformats.org/officeDocument/2006/relationships" xmlns:p="http://schemas.openxmlformats.org/presentationml/2006/main">
+  <p:cSld>
+    <p:bg>
+      <p:bgPr>
+        <a:solidFill>
+          <a:srgbClr val="0D0D1A"/>
+        </a:solidFill>
+        <a:effectLst/>
+      </p:bgPr>
+    </p:bg>
+    <p:spTree>
+      <p:nvGrpSpPr>
+        <p:cNvPr id="1" name=""/>
+        <p:cNvGrpSpPr/>
+        <p:nvPr/>
+      </p:nvGrpSpPr>
+      <p:grpSpPr>
+        <a:xfrm>
+          <a:off x="0" y="0"/>
+          <a:ext cx="0" cy="0"/>
+          <a:chOff x="0" y="0"/>
+          <a:chExt cx="0" cy="0"/>
+        </a:xfrm>
+      </p:grpSpPr>
+      <p:sp>
+        <p:nvSpPr>
+          <p:cNvPr id="2" name="AccentStripe"/>
+          <p:cNvSpPr/>
+          <p:nvPr/>
+        </p:nvSpPr>
+        <p:spPr>
+          <a:xfrm>
+            <a:off x="0" y="0"/>
+            <a:ext cx="91440" cy="5143500"/>
+          </a:xfrm>
+          <a:prstGeom prst="rect">
+            <a:avLst/>
+          </a:prstGeom>
+          <a:solidFill>
+            <a:srgbClr val="4472C4"/>
+          </a:solidFill>
+          <a:ln>
+            <a:solidFill/>
+          </a:ln>
+        </p:spPr>
+        <p:txBody>
+          <a:bodyPr/>
+          <a:lstStyle/>
+          <a:p>
+            <a:endParaRPr lang="de-DE"/>
+          </a:p>
+        </p:txBody>
+      </p:sp>
+      <p:sp>
+        <p:nvSpPr>
+          <p:cNvPr id="3" name="Title"/>
+          <p:cNvSpPr/>
+          <p:nvPr/>
+        </p:nvSpPr>
+        <p:spPr>
+          <a:xfrm>
+            <a:off x="457200" y="256032"/>
+            <a:ext cx="8229600" cy="594360"/>
+          </a:xfrm>
+          <a:prstGeom prst="rect">
+            <a:avLst/>
+          </a:prstGeom>
+          <a:noFill/>
+          <a:ln/>
+        </p:spPr>
+        <p:txBody>
+          <a:bodyPr wrap="square" lIns="114300" tIns="91440" rIns="114300" bIns="91440" rtlCol="0" anchor="ctr"/>
+          <a:lstStyle/>
+          <a:p>
+            <a:pPr marL="0" indent="0" algn="l">
+              <a:buNone/>
+            </a:pPr>
+            <a:r>
+              <a:rPr lang="de-DE" sz="2800" b="1" dirty="0">
+                <a:solidFill>
+                  <a:srgbClr val="FFFFFF"/>
+                </a:solidFill>
+                <a:latin typeface="Arial Black" pitchFamily="49" charset="0"/>
+              </a:rPr>
+              <a:t>database.py – Flexible Datenbankzugriffe</a:t>
+            </a:r>
+          </a:p>
+        </p:txBody>
+      </p:sp>
+      <p:sp>
+        <p:nvSpPr>
+          <p:cNvPr id="4" name="Subtitle"/>
+          <p:cNvSpPr/>
+          <p:nvPr/>
+        </p:nvSpPr>
+        <p:spPr>
+          <a:xfrm>
+            <a:off x="457200" y="804672"/>
+            <a:ext cx="8229600" cy="320040"/>
+          </a:xfrm>
+          <a:prstGeom prst="rect">
+            <a:avLst/>
+          </a:prstGeom>
+          <a:noFill/>
+          <a:ln/>
+        </p:spPr>
+        <p:txBody>
+          <a:bodyPr wrap="square" lIns="114300" tIns="91440" rIns="114300" bIns="91440" rtlCol="0" anchor="ctr"/>
+          <a:lstStyle/>
+          <a:p>
+            <a:pPr marL="0" indent="0" algn="l">
+              <a:buNone/>
+            </a:pPr>
+            <a:r>
+              <a:rPr lang="de-DE" sz="1200" dirty="0">
+                <a:solidFill>
+                  <a:srgbClr val="8892A4"/>
+                </a:solidFill>
+                <a:latin typeface="Calibri" pitchFamily="49" charset="0"/>
+              </a:rPr>
+              <a:t>row_factory · Schema-Migration · SQL-Injection-Schutz</a:t>
+            </a:r>
+          </a:p>
+        </p:txBody>
+      </p:sp>
+      <p:sp>
+        <p:nvSpPr>
+          <p:cNvPr id="5" name="CodeCard"/>
+          <p:cNvSpPr/>
+          <p:nvPr/>
+        </p:nvSpPr>
+        <p:spPr>
+          <a:xfrm>
+            <a:off x="365760" y="1234440"/>
+            <a:ext cx="5250000" cy="3650000"/>
+          </a:xfrm>
+          <a:prstGeom prst="rect">
+            <a:avLst/>
+          </a:prstGeom>
+          <a:solidFill>
+            <a:srgbClr val="121224"/>
+          </a:solidFill>
+          <a:ln w="9525">
+            <a:solidFill>
+              <a:srgbClr val="4472C4"/>
+            </a:solidFill>
+            <a:prstDash val="solid"/>
+          </a:ln>
+        </p:spPr>
+        <p:txBody>
+          <a:bodyPr/>
+          <a:lstStyle/>
+          <a:p>
+            <a:endParaRPr lang="de-DE"/>
+          </a:p>
+        </p:txBody>
+      </p:sp>
+      <p:sp>
+        <p:nvSpPr>
+          <p:cNvPr id="6" name="CodeText"/>
+          <p:cNvSpPr/>
+          <p:nvPr/>
+        </p:nvSpPr>
+        <p:spPr>
+          <a:xfrm>
+            <a:off x="457200" y="1325880"/>
+            <a:ext cx="5067120" cy="3467120"/>
+          </a:xfrm>
+          <a:prstGeom prst="rect">
+            <a:avLst/>
+          </a:prstGeom>
+          <a:noFill/>
+          <a:ln/>
+        </p:spPr>
+        <p:txBody>
+          <a:bodyPr wrap="square" lIns="114300" tIns="91440" rIns="114300" bIns="91440" rtlCol="0" anchor="t"/>
+          <a:lstStyle/>
+          <a:p>
+            <a:pPr marL="0" indent="0" algn="l">
+              <a:buNone/>
+            </a:pPr>
+            <a:r>
+              <a:rPr lang="de-DE" sz="980" i="1" dirty="0">
+                <a:solidFill>
+                  <a:srgbClr val="5C6370"/>
+                </a:solidFill>
+                <a:latin typeface="Consolas" pitchFamily="49" charset="0"/>
+              </a:rPr>
+              <a:t># row_factory: Spaltenzugriff per Name statt Index</a:t>
+            </a:r>
+          </a:p>
+          <a:p>
+            <a:pPr marL="0" indent="0" algn="l">
+              <a:buNone/>
+            </a:pPr>
+            <a:r>
+              <a:rPr lang="de-DE" sz="980" dirty="0">
+                <a:solidFill>
+                  <a:srgbClr val="56B6C2"/>
+                </a:solidFill>
+                <a:latin typeface="Consolas" pitchFamily="49" charset="0"/>
+              </a:rPr>
+              <a:t>conn</a:t>
+            </a:r>
+            <a:r>
+              <a:rPr lang="de-DE" sz="980" dirty="0">
+                <a:solidFill>
+                  <a:srgbClr val="ABB2BF"/>
+                </a:solidFill>
+                <a:latin typeface="Consolas" pitchFamily="49" charset="0"/>
+              </a:rPr>
+              <a:t>.row_factory = </a:t>
+            </a:r>
+            <a:r>
+              <a:rPr lang="de-DE" sz="980" dirty="0">
+                <a:solidFill>
+                  <a:srgbClr val="61AFEF"/>
+                </a:solidFill>
+                <a:latin typeface="Consolas" pitchFamily="49" charset="0"/>
+              </a:rPr>
+              <a:t>sqlite3</a:t>
+            </a:r>
+            <a:r>
+              <a:rPr lang="de-DE" sz="980" dirty="0">
+                <a:solidFill>
+                  <a:srgbClr val="ABB2BF"/>
+                </a:solidFill>
+                <a:latin typeface="Consolas" pitchFamily="49" charset="0"/>
+              </a:rPr>
+              <a:t>.Row</a:t>
+            </a:r>
+          </a:p>
+          <a:p>
+            <a:pPr marL="0" indent="0" algn="l">
+              <a:buNone/>
+            </a:pPr>
+            <a:r>
+              <a:rPr lang="de-DE" sz="980" dirty="0">
+                <a:solidFill>
+                  <a:srgbClr val="56B6C2"/>
+                </a:solidFill>
+                <a:latin typeface="Consolas" pitchFamily="49" charset="0"/>
+              </a:rPr>
+              <a:t>row</a:t>
+            </a:r>
+            <a:r>
+              <a:rPr lang="de-DE" sz="980" dirty="0">
+                <a:solidFill>
+                  <a:srgbClr val="ABB2BF"/>
+                </a:solidFill>
+                <a:latin typeface="Consolas" pitchFamily="49" charset="0"/>
+              </a:rPr>
+              <a:t> = cursor.</a:t>
+            </a:r>
+            <a:r>
+              <a:rPr lang="de-DE" sz="980" dirty="0">
+                <a:solidFill>
+                  <a:srgbClr val="61AFEF"/>
+                </a:solidFill>
+                <a:latin typeface="Consolas" pitchFamily="49" charset="0"/>
+              </a:rPr>
+              <a:t>fetchone</a:t>
+            </a:r>
+            <a:r>
+              <a:rPr lang="de-DE" sz="980" dirty="0">
+                <a:solidFill>
+                  <a:srgbClr val="ABB2BF"/>
+                </a:solidFill>
+                <a:latin typeface="Consolas" pitchFamily="49" charset="0"/>
+              </a:rPr>
+              <a:t>()</a:t>
+            </a:r>
+          </a:p>
+          <a:p>
+            <a:pPr marL="0" indent="0" algn="l">
+              <a:buNone/>
+            </a:pPr>
+            <a:r>
+              <a:rPr lang="de-DE" sz="980" dirty="0">
+                <a:solidFill>
+                  <a:srgbClr val="56B6C2"/>
+                </a:solidFill>
+                <a:latin typeface="Consolas" pitchFamily="49" charset="0"/>
+              </a:rPr>
+              <a:t>print</a:t>
+            </a:r>
+            <a:r>
+              <a:rPr lang="de-DE" sz="980" dirty="0">
+                <a:solidFill>
+                  <a:srgbClr val="ABB2BF"/>
+                </a:solidFill>
+                <a:latin typeface="Consolas" pitchFamily="49" charset="0"/>
+              </a:rPr>
+              <a:t>(row[</a:t>
+            </a:r>
+            <a:r>
+              <a:rPr lang="de-DE" sz="980" dirty="0">
+                <a:solidFill>
+                  <a:srgbClr val="98C379"/>
+                </a:solidFill>
+                <a:latin typeface="Consolas" pitchFamily="49" charset="0"/>
+              </a:rPr>
+              <a:t>"username"</a:t>
+            </a:r>
+            <a:r>
+              <a:rPr lang="de-DE" sz="980" dirty="0">
+                <a:solidFill>
+                  <a:srgbClr val="ABB2BF"/>
+                </a:solidFill>
+                <a:latin typeface="Consolas" pitchFamily="49" charset="0"/>
+              </a:rPr>
+              <a:t>])  </a:t>
+            </a:r>
+            <a:r>
+              <a:rPr lang="de-DE" sz="980" i="1" dirty="0">
+                <a:solidFill>
+                  <a:srgbClr val="5C6370"/>
+                </a:solidFill>
+                <a:latin typeface="Consolas" pitchFamily="49" charset="0"/>
+              </a:rPr>
+              <a:t># statt row[1]</a:t>
+            </a:r>
+          </a:p>
+          <a:p>
+            <a:pPr marL="0" indent="0" algn="l">
+              <a:buNone/>
+            </a:pPr>
+            <a:r>
+              <a:rPr lang="de-DE" sz="980" dirty="0">
+                <a:solidFill>
+                  <a:srgbClr val="56B6C2"/>
+                </a:solidFill>
+                <a:latin typeface="Consolas" pitchFamily="49" charset="0"/>
+              </a:rPr>
+              <a:t>return</a:t>
+            </a:r>
+            <a:r>
+              <a:rPr lang="de-DE" sz="980" dirty="0">
+                <a:solidFill>
+                  <a:srgbClr val="ABB2BF"/>
+                </a:solidFill>
+                <a:latin typeface="Consolas" pitchFamily="49" charset="0"/>
+              </a:rPr>
+              <a:t> </a:t>
+            </a:r>
+            <a:r>
+              <a:rPr lang="de-DE" sz="980" dirty="0">
+                <a:solidFill>
+                  <a:srgbClr val="61AFEF"/>
+                </a:solidFill>
+                <a:latin typeface="Consolas" pitchFamily="49" charset="0"/>
+              </a:rPr>
+              <a:t>dict</a:t>
+            </a:r>
+            <a:r>
+              <a:rPr lang="de-DE" sz="980" dirty="0">
+                <a:solidFill>
+                  <a:srgbClr val="ABB2BF"/>
+                </a:solidFill>
+                <a:latin typeface="Consolas" pitchFamily="49" charset="0"/>
+              </a:rPr>
+              <a:t>(row)      </a:t>
+            </a:r>
+            <a:r>
+              <a:rPr lang="de-DE" sz="980" i="1" dirty="0">
+                <a:solidFill>
+                  <a:srgbClr val="5C6370"/>
+                </a:solidFill>
+                <a:latin typeface="Consolas" pitchFamily="49" charset="0"/>
+              </a:rPr>
+              <a:t># einfache Serialisierung</a:t>
+            </a:r>
+          </a:p>
+          <a:p>
+            <a:pPr>
+              <a:buNone/>
+            </a:pPr>
+            <a:endParaRPr lang="de-DE" sz="600" dirty="0"/>
+          </a:p>
+          <a:p>
+            <a:pPr marL="0" indent="0" algn="l">
+              <a:buNone/>
+            </a:pPr>
+            <a:r>
+              <a:rPr lang="de-DE" sz="980" i="1" dirty="0">
+                <a:solidFill>
+                  <a:srgbClr val="5C6370"/>
+                </a:solidFill>
+                <a:latin typeface="Consolas" pitchFamily="49" charset="0"/>
+              </a:rPr>
+              <a:t># Schema-Migration: neue Spalte nachrüsten</a:t>
+            </a:r>
+          </a:p>
+          <a:p>
+            <a:pPr marL="0" indent="0" algn="l">
+              <a:buNone/>
+            </a:pPr>
+            <a:r>
+              <a:rPr lang="de-DE" sz="980" dirty="0">
+                <a:solidFill>
+                  <a:srgbClr val="56B6C2"/>
+                </a:solidFill>
+                <a:latin typeface="Consolas" pitchFamily="49" charset="0"/>
+              </a:rPr>
+              <a:t>try</a:t>
+            </a:r>
+            <a:r>
+              <a:rPr lang="de-DE" sz="980" dirty="0">
+                <a:solidFill>
+                  <a:srgbClr val="ABB2BF"/>
+                </a:solidFill>
+                <a:latin typeface="Consolas" pitchFamily="49" charset="0"/>
+              </a:rPr>
+              <a:t>:</a:t>
+            </a:r>
+          </a:p>
+          <a:p>
+            <a:pPr marL="0" indent="0" algn="l">
+              <a:buNone/>
+            </a:pPr>
+            <a:r>
+              <a:rPr lang="de-DE" sz="980" dirty="0">
+                <a:solidFill>
+                  <a:srgbClr val="ABB2BF"/>
+                </a:solidFill>
+                <a:latin typeface="Consolas" pitchFamily="49" charset="0"/>
+              </a:rPr>
+              <a:t>    cursor.</a:t>
+            </a:r>
+            <a:r>
+              <a:rPr lang="de-DE" sz="980" dirty="0">
+                <a:solidFill>
+                  <a:srgbClr val="61AFEF"/>
+                </a:solidFill>
+                <a:latin typeface="Consolas" pitchFamily="49" charset="0"/>
+              </a:rPr>
+              <a:t>execute</a:t>
+            </a:r>
+            <a:r>
+              <a:rPr lang="de-DE" sz="980" dirty="0">
+                <a:solidFill>
+                  <a:srgbClr val="ABB2BF"/>
+                </a:solidFill>
+                <a:latin typeface="Consolas" pitchFamily="49" charset="0"/>
+              </a:rPr>
+              <a:t>(</a:t>
+            </a:r>
+          </a:p>
+          <a:p>
+            <a:pPr marL="0" indent="0" algn="l">
+              <a:buNone/>
+            </a:pPr>
+            <a:r>
+              <a:rPr lang="de-DE" sz="980" dirty="0">
+                <a:solidFill>
+                  <a:srgbClr val="ABB2BF"/>
+                </a:solidFill>
+                <a:latin typeface="Consolas" pitchFamily="49" charset="0"/>
+              </a:rPr>
+              <a:t>        </a:t>
+            </a:r>
+            <a:r>
+              <a:rPr lang="de-DE" sz="980" dirty="0">
+                <a:solidFill>
+                  <a:srgbClr val="98C379"/>
+                </a:solidFill>
+                <a:latin typeface="Consolas" pitchFamily="49" charset="0"/>
+              </a:rPr>
+              <a:t>"ALTER TABLE users"</a:t>
+            </a:r>
+          </a:p>
+          <a:p>
+            <a:pPr marL="0" indent="0" algn="l">
+              <a:buNone/>
+            </a:pPr>
+            <a:r>
+              <a:rPr lang="de-DE" sz="980" dirty="0">
+                <a:solidFill>
+                  <a:srgbClr val="ABB2BF"/>
+                </a:solidFill>
+                <a:latin typeface="Consolas" pitchFamily="49" charset="0"/>
+              </a:rPr>
+              <a:t>        </a:t>
+            </a:r>
+            <a:r>
+              <a:rPr lang="de-DE" sz="980" dirty="0">
+                <a:solidFill>
+                  <a:srgbClr val="98C379"/>
+                </a:solidFill>
+                <a:latin typeface="Consolas" pitchFamily="49" charset="0"/>
+              </a:rPr>
+              <a:t>"ADD COLUMN language TEXT DEFAULT 'en'"</a:t>
+            </a:r>
+          </a:p>
+          <a:p>
+            <a:pPr marL="0" indent="0" algn="l">
+              <a:buNone/>
+            </a:pPr>
+            <a:r>
+              <a:rPr lang="de-DE" sz="980" dirty="0">
+                <a:solidFill>
+                  <a:srgbClr val="ABB2BF"/>
+                </a:solidFill>
+                <a:latin typeface="Consolas" pitchFamily="49" charset="0"/>
+              </a:rPr>
+              <a:t>    )</a:t>
+            </a:r>
+          </a:p>
+          <a:p>
+            <a:pPr marL="0" indent="0" algn="l">
+              <a:buNone/>
+            </a:pPr>
+            <a:r>
+              <a:rPr lang="de-DE" sz="980" dirty="0">
+                <a:solidFill>
+                  <a:srgbClr val="ABB2BF"/>
+                </a:solidFill>
+                <a:latin typeface="Consolas" pitchFamily="49" charset="0"/>
+              </a:rPr>
+              <a:t>    conn.</a:t>
+            </a:r>
+            <a:r>
+              <a:rPr lang="de-DE" sz="980" dirty="0">
+                <a:solidFill>
+                  <a:srgbClr val="61AFEF"/>
+                </a:solidFill>
+                <a:latin typeface="Consolas" pitchFamily="49" charset="0"/>
+              </a:rPr>
+              <a:t>commit</a:t>
+            </a:r>
+            <a:r>
+              <a:rPr lang="de-DE" sz="980" dirty="0">
+                <a:solidFill>
+                  <a:srgbClr val="ABB2BF"/>
+                </a:solidFill>
+                <a:latin typeface="Consolas" pitchFamily="49" charset="0"/>
+              </a:rPr>
+              <a:t>()</a:t>
+            </a:r>
+          </a:p>
+          <a:p>
+            <a:pPr marL="0" indent="0" algn="l">
+              <a:buNone/>
+            </a:pPr>
+            <a:r>
+              <a:rPr lang="de-DE" sz="980" dirty="0">
+                <a:solidFill>
+                  <a:srgbClr val="56B6C2"/>
+                </a:solidFill>
+                <a:latin typeface="Consolas" pitchFamily="49" charset="0"/>
+              </a:rPr>
+              <a:t>except</a:t>
+            </a:r>
+            <a:r>
+              <a:rPr lang="de-DE" sz="980" dirty="0">
+                <a:solidFill>
+                  <a:srgbClr val="ABB2BF"/>
+                </a:solidFill>
+                <a:latin typeface="Consolas" pitchFamily="49" charset="0"/>
+              </a:rPr>
+              <a:t> sqlite3.</a:t>
+            </a:r>
+            <a:r>
+              <a:rPr lang="de-DE" sz="980" dirty="0">
+                <a:solidFill>
+                  <a:srgbClr val="61AFEF"/>
+                </a:solidFill>
+                <a:latin typeface="Consolas" pitchFamily="49" charset="0"/>
+              </a:rPr>
+              <a:t>OperationalError</a:t>
+            </a:r>
+            <a:r>
+              <a:rPr lang="de-DE" sz="980" dirty="0">
+                <a:solidFill>
+                  <a:srgbClr val="ABB2BF"/>
+                </a:solidFill>
+                <a:latin typeface="Consolas" pitchFamily="49" charset="0"/>
+              </a:rPr>
+              <a:t>:</a:t>
+            </a:r>
+          </a:p>
+          <a:p>
+            <a:pPr marL="0" indent="0" algn="l">
+              <a:buNone/>
+            </a:pPr>
+            <a:r>
+              <a:rPr lang="de-DE" sz="980" dirty="0">
+                <a:solidFill>
+                  <a:srgbClr val="ABB2BF"/>
+                </a:solidFill>
+                <a:latin typeface="Consolas" pitchFamily="49" charset="0"/>
+              </a:rPr>
+              <a:t>    </a:t>
+            </a:r>
+            <a:r>
+              <a:rPr lang="de-DE" sz="980" dirty="0">
+                <a:solidFill>
+                  <a:srgbClr val="56B6C2"/>
+                </a:solidFill>
+                <a:latin typeface="Consolas" pitchFamily="49" charset="0"/>
+              </a:rPr>
+              <a:t>pass</a:t>
+            </a:r>
+            <a:r>
+              <a:rPr lang="de-DE" sz="980" dirty="0">
+                <a:solidFill>
+                  <a:srgbClr val="ABB2BF"/>
+                </a:solidFill>
+                <a:latin typeface="Consolas" pitchFamily="49" charset="0"/>
+              </a:rPr>
+              <a:t>  </a:t>
+            </a:r>
+            <a:r>
+              <a:rPr lang="de-DE" sz="980" i="1" dirty="0">
+                <a:solidFill>
+                  <a:srgbClr val="5C6370"/>
+                </a:solidFill>
+                <a:latin typeface="Consolas" pitchFamily="49" charset="0"/>
+              </a:rPr>
+              <a:t># Spalte existiert bereits</a:t>
+            </a:r>
+          </a:p>
+          <a:p>
+            <a:pPr>
+              <a:buNone/>
+            </a:pPr>
+            <a:endParaRPr lang="de-DE" sz="600" dirty="0"/>
+          </a:p>
+          <a:p>
+            <a:pPr marL="0" indent="0" algn="l">
+              <a:buNone/>
+            </a:pPr>
+            <a:r>
+              <a:rPr lang="de-DE" sz="980" i="1" dirty="0">
+                <a:solidFill>
+                  <a:srgbClr val="5C6370"/>
+                </a:solidFill>
+                <a:latin typeface="Consolas" pitchFamily="49" charset="0"/>
+              </a:rPr>
+              <a:t># SQL-Injection-Schutz: Parameterized Queries</a:t>
+            </a:r>
+          </a:p>
+          <a:p>
+            <a:pPr marL="0" indent="0" algn="l">
+              <a:buNone/>
+            </a:pPr>
+            <a:r>
+              <a:rPr lang="de-DE" sz="980" dirty="0">
+                <a:solidFill>
+                  <a:srgbClr val="ABB2BF"/>
+                </a:solidFill>
+                <a:latin typeface="Consolas" pitchFamily="49" charset="0"/>
+              </a:rPr>
+              <a:t>cursor.</a:t>
+            </a:r>
+            <a:r>
+              <a:rPr lang="de-DE" sz="980" dirty="0">
+                <a:solidFill>
+                  <a:srgbClr val="61AFEF"/>
+                </a:solidFill>
+                <a:latin typeface="Consolas" pitchFamily="49" charset="0"/>
+              </a:rPr>
+              <a:t>execute</a:t>
+            </a:r>
+            <a:r>
+              <a:rPr lang="de-DE" sz="980" dirty="0">
+                <a:solidFill>
+                  <a:srgbClr val="ABB2BF"/>
+                </a:solidFill>
+                <a:latin typeface="Consolas" pitchFamily="49" charset="0"/>
+              </a:rPr>
+              <a:t>(</a:t>
+            </a:r>
+          </a:p>
+          <a:p>
+            <a:pPr marL="0" indent="0" algn="l">
+              <a:buNone/>
+            </a:pPr>
+            <a:r>
+              <a:rPr lang="de-DE" sz="980" dirty="0">
+                <a:solidFill>
+                  <a:srgbClr val="ABB2BF"/>
+                </a:solidFill>
+                <a:latin typeface="Consolas" pitchFamily="49" charset="0"/>
+              </a:rPr>
+              <a:t>    </a:t>
+            </a:r>
+            <a:r>
+              <a:rPr lang="de-DE" sz="980" dirty="0">
+                <a:solidFill>
+                  <a:srgbClr val="98C379"/>
+                </a:solidFill>
+                <a:latin typeface="Consolas" pitchFamily="49" charset="0"/>
+              </a:rPr>
+              <a:t>"SELECT * FROM users WHERE username = ?"</a:t>
+            </a:r>
+            <a:r>
+              <a:rPr lang="de-DE" sz="980" dirty="0">
+                <a:solidFill>
+                  <a:srgbClr val="ABB2BF"/>
+                </a:solidFill>
+                <a:latin typeface="Consolas" pitchFamily="49" charset="0"/>
+              </a:rPr>
+              <a:t>,</a:t>
+            </a:r>
+          </a:p>
+          <a:p>
+            <a:pPr marL="0" indent="0" algn="l">
+              <a:buNone/>
+            </a:pPr>
+            <a:r>
+              <a:rPr lang="de-DE" sz="980" dirty="0">
+                <a:solidFill>
+                  <a:srgbClr val="ABB2BF"/>
+                </a:solidFill>
+                <a:latin typeface="Consolas" pitchFamily="49" charset="0"/>
+              </a:rPr>
+              <a:t>    (username,)  </a:t>
+            </a:r>
+            <a:r>
+              <a:rPr lang="de-DE" sz="980" i="1" dirty="0">
+                <a:solidFill>
+                  <a:srgbClr val="5C6370"/>
+                </a:solidFill>
+                <a:latin typeface="Consolas" pitchFamily="49" charset="0"/>
+              </a:rPr>
+              <a:t># ? wird sicher ersetzt</a:t>
+            </a:r>
+          </a:p>
+          <a:p>
+            <a:pPr marL="0" indent="0" algn="l">
+              <a:buNone/>
+            </a:pPr>
+            <a:r>
+              <a:rPr lang="de-DE" sz="980" dirty="0">
+                <a:solidFill>
+                  <a:srgbClr val="ABB2BF"/>
+                </a:solidFill>
+                <a:latin typeface="Consolas" pitchFamily="49" charset="0"/>
+              </a:rPr>
+              <a:t>)</a:t>
+            </a:r>
+          </a:p>
+        </p:txBody>
+      </p:sp>
+      <p:sp>
+        <p:nvSpPr>
+          <p:cNvPr id="7" name="BulletCard"/>
+          <p:cNvSpPr/>
+          <p:nvPr/>
+        </p:nvSpPr>
+        <p:spPr>
+          <a:xfrm>
+            <a:off x="5707200" y="1234440"/>
+            <a:ext cx="3071040" cy="3650000"/>
+          </a:xfrm>
+          <a:prstGeom prst="rect">
+            <a:avLst/>
+          </a:prstGeom>
+          <a:solidFill>
+            <a:srgbClr val="161638"/>
+          </a:solidFill>
+          <a:ln w="6350">
+            <a:solidFill>
+              <a:srgbClr val="D0D7E8"/>
+            </a:solidFill>
+            <a:prstDash val="solid"/>
+          </a:ln>
+        </p:spPr>
+        <p:txBody>
+          <a:bodyPr/>
+          <a:lstStyle/>
+          <a:p>
+            <a:endParaRPr lang="de-DE"/>
+          </a:p>
+        </p:txBody>
+      </p:sp>
+      <p:sp>
+        <p:nvSpPr>
+          <p:cNvPr id="8" name="BulletText"/>
+          <p:cNvSpPr/>
+          <p:nvPr/>
+        </p:nvSpPr>
+        <p:spPr>
+          <a:xfrm>
+            <a:off x="5798640" y="1325880"/>
+            <a:ext cx="2888160" cy="3467120"/>
+          </a:xfrm>
+          <a:prstGeom prst="rect">
+            <a:avLst/>
+          </a:prstGeom>
+          <a:noFill/>
+          <a:ln/>
+        </p:spPr>
+        <p:txBody>
+          <a:bodyPr wrap="square" lIns="114300" tIns="91440" rIns="114300" bIns="91440" rtlCol="0" anchor="t"/>
+          <a:lstStyle/>
+          <a:p>
+            <a:pPr marL="342900" indent="-342900" algn="l">
+              <a:buChar char="▸"/>
+            </a:pPr>
+            <a:r>
+              <a:rPr lang="de-DE" sz="1150" b="1" dirty="0">
+                <a:solidFill>
+                  <a:srgbClr val="FFFFFF"/>
+                </a:solidFill>
+                <a:latin typeface="Calibri" pitchFamily="49" charset="0"/>
+              </a:rPr>
+              <a:t>sqlite3.Row</a:t>
+            </a:r>
+          </a:p>
+          <a:p>
+            <a:pPr marL="342900" indent="0" algn="l">
+              <a:buNone/>
+            </a:pPr>
+            <a:r>
+              <a:rPr lang="de-DE" sz="1000" dirty="0">
+                <a:solidFill>
+                  <a:srgbClr val="8892A4"/>
+                </a:solidFill>
+                <a:latin typeface="Calibri" pitchFamily="49" charset="0"/>
+              </a:rPr>
+              <a:t>Spaltenzugriff per Name: row["username"] statt row[1]</a:t>
+            </a:r>
+          </a:p>
+          <a:p>
+            <a:pPr marL="342900" indent="-342900" algn="l">
+              <a:spcBef>
+                <a:spcPts val="160"/>
+              </a:spcBef>
+              <a:buChar char="▸"/>
+            </a:pPr>
+            <a:r>
+              <a:rPr lang="de-DE" sz="1150" b="1" dirty="0">
+                <a:solidFill>
+                  <a:srgbClr val="FFFFFF"/>
+                </a:solidFill>
+                <a:latin typeface="Calibri" pitchFamily="49" charset="0"/>
+              </a:rPr>
+              <a:t>dict(row)</a:t>
+            </a:r>
+          </a:p>
+          <a:p>
+            <a:pPr marL="342900" indent="0" algn="l">
+              <a:buNone/>
+            </a:pPr>
+            <a:r>
+              <a:rPr lang="de-DE" sz="1000" dirty="0">
+                <a:solidFill>
+                  <a:srgbClr val="8892A4"/>
+                </a:solidFill>
+                <a:latin typeface="Calibri" pitchFamily="49" charset="0"/>
+              </a:rPr>
+              <a:t>Einfache Konvertierung für den Rest der App</a:t>
+            </a:r>
+          </a:p>
+          <a:p>
+            <a:pPr marL="342900" indent="-342900" algn="l">
+              <a:spcBef>
+                <a:spcPts val="160"/>
+              </a:spcBef>
+              <a:buChar char="▸"/>
+            </a:pPr>
+            <a:r>
+              <a:rPr lang="de-DE" sz="1150" b="1" dirty="0">
+                <a:solidFill>
+                  <a:srgbClr val="FFFFFF"/>
+                </a:solidFill>
+                <a:latin typeface="Calibri" pitchFamily="49" charset="0"/>
+              </a:rPr>
+              <a:t>try/except Migration</a:t>
+            </a:r>
+          </a:p>
+          <a:p>
+            <a:pPr marL="342900" indent="0" algn="l">
+              <a:buNone/>
+            </a:pPr>
+            <a:r>
+              <a:rPr lang="de-DE" sz="1000" dirty="0">
+                <a:solidFill>
+                  <a:srgbClr val="8892A4"/>
+                </a:solidFill>
+                <a:latin typeface="Calibri" pitchFamily="49" charset="0"/>
+              </a:rPr>
+              <a:t>DB bleibt kompatibel wenn Spalte schon existiert</a:t>
+            </a:r>
+          </a:p>
+          <a:p>
+            <a:pPr marL="342900" indent="-342900" algn="l">
+              <a:spcBef>
+                <a:spcPts val="160"/>
+              </a:spcBef>
+              <a:buChar char="▸"/>
+            </a:pPr>
+            <a:r>
+              <a:rPr lang="de-DE" sz="1150" b="1" dirty="0">
+                <a:solidFill>
+                  <a:srgbClr val="FFFFFF"/>
+                </a:solidFill>
+                <a:latin typeface="Calibri" pitchFamily="49" charset="0"/>
+              </a:rPr>
+              <a:t>?-Platzhalter</a:t>
+            </a:r>
+          </a:p>
+          <a:p>
+            <a:pPr marL="342900" indent="0" algn="l">
+              <a:buNone/>
+            </a:pPr>
+            <a:r>
+              <a:rPr lang="de-DE" sz="1000" dirty="0">
+                <a:solidFill>
+                  <a:srgbClr val="8892A4"/>
+                </a:solidFill>
+                <a:latin typeface="Calibri" pitchFamily="49" charset="0"/>
+              </a:rPr>
+              <a:t>Schutz vor SQL-Injection (OWASP Top 10)</a:t>
+            </a:r>
+          </a:p>
+          <a:p>
+            <a:pPr marL="342900" indent="-342900" algn="l">
+              <a:spcBef>
+                <a:spcPts val="160"/>
+              </a:spcBef>
+              <a:buChar char="▸"/>
+            </a:pPr>
+            <a:r>
+              <a:rPr lang="de-DE" sz="1150" b="1" dirty="0">
+                <a:solidFill>
+                  <a:srgbClr val="FFFFFF"/>
+                </a:solidFill>
+                <a:latin typeface="Calibri" pitchFamily="49" charset="0"/>
+              </a:rPr>
+              <a:t>IntegrityError</a:t>
+            </a:r>
+          </a:p>
+          <a:p>
+            <a:pPr marL="342900" indent="0" algn="l">
+              <a:buNone/>
+            </a:pPr>
+            <a:r>
+              <a:rPr lang="de-DE" sz="1000" dirty="0">
+                <a:solidFill>
+                  <a:srgbClr val="8892A4"/>
+                </a:solidFill>
+                <a:latin typeface="Calibri" pitchFamily="49" charset="0"/>
+              </a:rPr>
+              <a:t>Doppelte Benutzernamen werden sauber abgefangen</a:t>
+            </a:r>
+          </a:p>
+        </p:txBody>
+      </p:sp>
+      <p:sp>
+        <p:nvSpPr>
+          <p:cNvPr id="9" name="Textfeld 8">
+            <a:extLst>
+              <a:ext uri="{FF2B5EF4-FFF2-40B4-BE49-F238E27FC236}">
+                <a16:creationId xmlns:a16="http://schemas.microsoft.com/office/drawing/2014/main" id="{3FE34108-9161-8AE9-4D11-BFE9571AD1A5}"/>
+              </a:ext>
+            </a:extLst>
+          </p:cNvPr>
+          <p:cNvSpPr txBox="1"/>
+          <p:nvPr/>
+        </p:nvSpPr>
+        <p:spPr>
+          <a:xfrm>
+            <a:off x="8737093" y="4875028"/>
+            <a:ext cx="228600" cy="215444"/>
+          </a:xfrm>
+          <a:prstGeom prst="rect">
+            <a:avLst/>
+          </a:prstGeom>
+          <a:noFill/>
+        </p:spPr>
+        <p:txBody>
+          <a:bodyPr wrap="square" rtlCol="0">
+            <a:spAutoFit/>
+          </a:bodyPr>
+          <a:lstStyle/>
+          <a:p>
+            <a:r>
+              <a:rPr lang="en-US" sz="800" dirty="0">
+                <a:solidFill>
+                  <a:srgbClr val="FFFFFF"/>
                 </a:solidFill>
                 <a:latin typeface="Calibri" pitchFamily="34" charset="0"/>
                 <a:ea typeface="Calibri" pitchFamily="34" charset="-122"/>
@@ -21735,6 +21847,9 @@
           <a:solidFill>
             <a:srgbClr val="E94560"/>
           </a:solidFill>
+          <a:ln>
+            <a:solidFill/>
+          </a:ln>
         </p:spPr>
         <p:txBody>
           <a:bodyPr/>
@@ -22514,7 +22629,7 @@
           </a:solidFill>
           <a:ln w="6350">
             <a:solidFill>
-              <a:srgbClr val="2A3A5E"/>
+              <a:srgbClr val="D0D7E8"/>
             </a:solidFill>
             <a:prstDash val="solid"/>
           </a:ln>
@@ -22732,7 +22847,7 @@
             <a:r>
               <a:rPr lang="en-US" sz="800" dirty="0">
                 <a:solidFill>
-                  <a:srgbClr val="E94560"/>
+                  <a:srgbClr val="FFFFFF"/>
                 </a:solidFill>
                 <a:latin typeface="Calibri" pitchFamily="34" charset="0"/>
                 <a:ea typeface="Calibri" pitchFamily="34" charset="-122"/>
@@ -22758,7 +22873,7 @@
     <p:bg>
       <p:bgPr>
         <a:solidFill>
-          <a:srgbClr val="F0F4FF"/>
+          <a:srgbClr val="0D0D1A"/>
         </a:solidFill>
         <a:effectLst/>
       </p:bgPr>
@@ -22804,7 +22919,7 @@
             <a:r>
               <a:rPr lang="en-US" sz="2800" b="1" dirty="0">
                 <a:solidFill>
-                  <a:srgbClr val="1A1A2E"/>
+                  <a:srgbClr val="FFFFFF"/>
                 </a:solidFill>
                 <a:latin typeface="Arial Black" pitchFamily="34" charset="0"/>
                 <a:ea typeface="Arial Black" pitchFamily="34" charset="-122"/>
@@ -22870,7 +22985,7 @@
             <a:avLst/>
           </a:prstGeom>
           <a:solidFill>
-            <a:srgbClr val="FFFFFF"/>
+            <a:srgbClr val="161638"/>
           </a:solidFill>
           <a:ln w="6350">
             <a:solidFill>
@@ -22921,7 +23036,7 @@
             <a:r>
               <a:rPr lang="en-US" sz="1500" b="1" dirty="0">
                 <a:solidFill>
-                  <a:srgbClr val="1A1A2E"/>
+                  <a:srgbClr val="FFFFFF"/>
                 </a:solidFill>
                 <a:latin typeface="Calibri" pitchFamily="34" charset="0"/>
                 <a:ea typeface="Calibri" pitchFamily="34" charset="-122"/>
@@ -22961,7 +23076,7 @@
             <a:r>
               <a:rPr lang="en-US" sz="1200" b="1" dirty="0">
                 <a:solidFill>
-                  <a:srgbClr val="1A1A2E"/>
+                  <a:srgbClr val="FFFFFF"/>
                 </a:solidFill>
                 <a:latin typeface="Calibri" pitchFamily="34" charset="0"/>
                 <a:ea typeface="Calibri" pitchFamily="34" charset="-122"/>
@@ -22978,7 +23093,7 @@
             <a:r>
               <a:rPr lang="en-US" sz="1200" dirty="0">
                 <a:solidFill>
-                  <a:srgbClr val="444444"/>
+                  <a:srgbClr val="D0D7E8"/>
                 </a:solidFill>
                 <a:latin typeface="Calibri" pitchFamily="34" charset="0"/>
                 <a:ea typeface="Calibri" pitchFamily="34" charset="-122"/>
@@ -23013,7 +23128,7 @@
             <a:r>
               <a:rPr lang="en-US" sz="1200" b="1" dirty="0">
                 <a:solidFill>
-                  <a:srgbClr val="1A1A2E"/>
+                  <a:srgbClr val="FFFFFF"/>
                 </a:solidFill>
                 <a:latin typeface="Calibri" pitchFamily="34" charset="0"/>
                 <a:ea typeface="Calibri" pitchFamily="34" charset="-122"/>
@@ -23030,7 +23145,7 @@
             <a:r>
               <a:rPr lang="en-US" sz="1200" dirty="0">
                 <a:solidFill>
-                  <a:srgbClr val="444444"/>
+                  <a:srgbClr val="D0D7E8"/>
                 </a:solidFill>
                 <a:latin typeface="Calibri" pitchFamily="34" charset="0"/>
                 <a:ea typeface="Calibri" pitchFamily="34" charset="-122"/>
@@ -23082,7 +23197,7 @@
             <a:r>
               <a:rPr lang="en-US" sz="1200" dirty="0">
                 <a:solidFill>
-                  <a:srgbClr val="444444"/>
+                  <a:srgbClr val="D0D7E8"/>
                 </a:solidFill>
                 <a:latin typeface="Calibri" pitchFamily="34" charset="0"/>
                 <a:ea typeface="Calibri" pitchFamily="34" charset="-122"/>
@@ -23117,7 +23232,7 @@
             <a:r>
               <a:rPr lang="en-US" sz="1200" b="1" dirty="0">
                 <a:solidFill>
-                  <a:srgbClr val="1A1A2E"/>
+                  <a:srgbClr val="FFFFFF"/>
                 </a:solidFill>
                 <a:latin typeface="Calibri" pitchFamily="34" charset="0"/>
                 <a:ea typeface="Calibri" pitchFamily="34" charset="-122"/>
@@ -23134,7 +23249,7 @@
             <a:r>
               <a:rPr lang="en-US" sz="1200" dirty="0">
                 <a:solidFill>
-                  <a:srgbClr val="444444"/>
+                  <a:srgbClr val="D0D7E8"/>
                 </a:solidFill>
                 <a:latin typeface="Calibri" pitchFamily="34" charset="0"/>
                 <a:ea typeface="Calibri" pitchFamily="34" charset="-122"/>
@@ -23161,7 +23276,7 @@
             <a:avLst/>
           </a:prstGeom>
           <a:solidFill>
-            <a:srgbClr val="FFFFFF"/>
+            <a:srgbClr val="161638"/>
           </a:solidFill>
           <a:ln w="6350">
             <a:solidFill>
@@ -23212,7 +23327,7 @@
             <a:r>
               <a:rPr lang="en-US" sz="1500" b="1" dirty="0">
                 <a:solidFill>
-                  <a:srgbClr val="1A1A2E"/>
+                  <a:srgbClr val="FFFFFF"/>
                 </a:solidFill>
                 <a:latin typeface="Calibri" pitchFamily="34" charset="0"/>
                 <a:ea typeface="Calibri" pitchFamily="34" charset="-122"/>
@@ -23241,11 +23356,11 @@
             </a:avLst>
           </a:prstGeom>
           <a:solidFill>
-            <a:srgbClr val="F8FAFF"/>
+            <a:srgbClr val="161638"/>
           </a:solidFill>
           <a:ln w="6350">
             <a:solidFill>
-              <a:srgbClr val="E0E8F8"/>
+              <a:srgbClr val="D0D7E8"/>
             </a:solidFill>
             <a:prstDash val="solid"/>
           </a:ln>
@@ -23317,7 +23432,7 @@
             <a:r>
               <a:rPr lang="en-US" sz="1200" b="1" dirty="0">
                 <a:solidFill>
-                  <a:srgbClr val="1A1A2E"/>
+                  <a:srgbClr val="FFFFFF"/>
                 </a:solidFill>
                 <a:latin typeface="Calibri" pitchFamily="34" charset="0"/>
                 <a:ea typeface="Calibri" pitchFamily="34" charset="-122"/>
@@ -23424,11 +23539,11 @@
             </a:avLst>
           </a:prstGeom>
           <a:solidFill>
-            <a:srgbClr val="F8FAFF"/>
+            <a:srgbClr val="161638"/>
           </a:solidFill>
           <a:ln w="6350">
             <a:solidFill>
-              <a:srgbClr val="E0E8F8"/>
+              <a:srgbClr val="D0D7E8"/>
             </a:solidFill>
             <a:prstDash val="solid"/>
           </a:ln>
@@ -23500,7 +23615,7 @@
             <a:r>
               <a:rPr lang="en-US" sz="1200" b="1" dirty="0">
                 <a:solidFill>
-                  <a:srgbClr val="1A1A2E"/>
+                  <a:srgbClr val="FFFFFF"/>
                 </a:solidFill>
                 <a:latin typeface="Calibri" pitchFamily="34" charset="0"/>
                 <a:ea typeface="Calibri" pitchFamily="34" charset="-122"/>
@@ -23607,11 +23722,11 @@
             </a:avLst>
           </a:prstGeom>
           <a:solidFill>
-            <a:srgbClr val="F8FAFF"/>
+            <a:srgbClr val="161638"/>
           </a:solidFill>
           <a:ln w="6350">
             <a:solidFill>
-              <a:srgbClr val="E0E8F8"/>
+              <a:srgbClr val="D0D7E8"/>
             </a:solidFill>
             <a:prstDash val="solid"/>
           </a:ln>
@@ -23683,7 +23798,7 @@
             <a:r>
               <a:rPr lang="en-US" sz="1200" b="1" dirty="0">
                 <a:solidFill>
-                  <a:srgbClr val="1A1A2E"/>
+                  <a:srgbClr val="FFFFFF"/>
                 </a:solidFill>
                 <a:latin typeface="Calibri" pitchFamily="34" charset="0"/>
                 <a:ea typeface="Calibri" pitchFamily="34" charset="-122"/>
@@ -23790,11 +23905,11 @@
             </a:avLst>
           </a:prstGeom>
           <a:solidFill>
-            <a:srgbClr val="F8FAFF"/>
+            <a:srgbClr val="161638"/>
           </a:solidFill>
           <a:ln w="6350">
             <a:solidFill>
-              <a:srgbClr val="E0E8F8"/>
+              <a:srgbClr val="D0D7E8"/>
             </a:solidFill>
             <a:prstDash val="solid"/>
           </a:ln>
@@ -23866,7 +23981,7 @@
             <a:r>
               <a:rPr lang="en-US" sz="1200" b="1" dirty="0">
                 <a:solidFill>
-                  <a:srgbClr val="1A1A2E"/>
+                  <a:srgbClr val="FFFFFF"/>
                 </a:solidFill>
                 <a:latin typeface="Calibri" pitchFamily="34" charset="0"/>
                 <a:ea typeface="Calibri" pitchFamily="34" charset="-122"/>
@@ -23973,11 +24088,11 @@
             </a:avLst>
           </a:prstGeom>
           <a:solidFill>
-            <a:srgbClr val="F8FAFF"/>
+            <a:srgbClr val="161638"/>
           </a:solidFill>
           <a:ln w="6350">
             <a:solidFill>
-              <a:srgbClr val="E0E8F8"/>
+              <a:srgbClr val="D0D7E8"/>
             </a:solidFill>
             <a:prstDash val="solid"/>
           </a:ln>
@@ -24049,7 +24164,7 @@
             <a:r>
               <a:rPr lang="en-US" sz="1200" b="1" dirty="0">
                 <a:solidFill>
-                  <a:srgbClr val="1A1A2E"/>
+                  <a:srgbClr val="FFFFFF"/>
                 </a:solidFill>
                 <a:latin typeface="Calibri" pitchFamily="34" charset="0"/>
                 <a:ea typeface="Calibri" pitchFamily="34" charset="-122"/>
@@ -24169,6 +24284,9 @@
           <a:p>
             <a:r>
               <a:rPr lang="en-US" sz="800" dirty="0">
+                <a:solidFill>
+                  <a:srgbClr val="FFFFFF"/>
+                </a:solidFill>
                 <a:latin typeface="Calibri" pitchFamily="34" charset="0"/>
                 <a:ea typeface="Calibri" pitchFamily="34" charset="-122"/>
                 <a:cs typeface="Calibri" pitchFamily="34" charset="-120"/>
@@ -24193,7 +24311,7 @@
     <p:bg>
       <p:bgPr>
         <a:solidFill>
-          <a:srgbClr val="F0F4FF"/>
+          <a:srgbClr val="0D0D1A"/>
         </a:solidFill>
         <a:effectLst/>
       </p:bgPr>
@@ -24229,6 +24347,9 @@
           <a:solidFill>
             <a:srgbClr val="4472C4"/>
           </a:solidFill>
+          <a:ln>
+            <a:solidFill/>
+          </a:ln>
         </p:spPr>
         <p:txBody>
           <a:bodyPr/>
@@ -24265,7 +24386,7 @@
             <a:r>
               <a:rPr lang="de-DE" sz="2800" b="1" dirty="0">
                 <a:solidFill>
-                  <a:srgbClr val="1A1A2E"/>
+                  <a:srgbClr val="FFFFFF"/>
                 </a:solidFill>
                 <a:latin typeface="Arial Black" pitchFamily="49" charset="0"/>
               </a:rPr>
@@ -25018,7 +25139,7 @@
             <a:avLst/>
           </a:prstGeom>
           <a:solidFill>
-            <a:srgbClr val="FFFFFF"/>
+            <a:srgbClr val="161638"/>
           </a:solidFill>
           <a:ln w="6350">
             <a:solidFill>
@@ -25062,7 +25183,7 @@
             <a:r>
               <a:rPr lang="de-DE" sz="1150" b="1" dirty="0">
                 <a:solidFill>
-                  <a:srgbClr val="2A3A5E"/>
+                  <a:srgbClr val="FFFFFF"/>
                 </a:solidFill>
                 <a:latin typeface="Calibri" pitchFamily="49" charset="0"/>
               </a:rPr>
@@ -25093,7 +25214,7 @@
             <a:r>
               <a:rPr lang="de-DE" sz="1150" b="1" dirty="0">
                 <a:solidFill>
-                  <a:srgbClr val="2A3A5E"/>
+                  <a:srgbClr val="FFFFFF"/>
                 </a:solidFill>
                 <a:latin typeface="Calibri" pitchFamily="49" charset="0"/>
               </a:rPr>
@@ -25124,7 +25245,7 @@
             <a:r>
               <a:rPr lang="de-DE" sz="1150" b="1" dirty="0">
                 <a:solidFill>
-                  <a:srgbClr val="2A3A5E"/>
+                  <a:srgbClr val="FFFFFF"/>
                 </a:solidFill>
                 <a:latin typeface="Calibri" pitchFamily="49" charset="0"/>
               </a:rPr>
@@ -25155,7 +25276,7 @@
             <a:r>
               <a:rPr lang="de-DE" sz="1150" b="1" dirty="0">
                 <a:solidFill>
-                  <a:srgbClr val="2A3A5E"/>
+                  <a:srgbClr val="FFFFFF"/>
                 </a:solidFill>
                 <a:latin typeface="Calibri" pitchFamily="49" charset="0"/>
               </a:rPr>
@@ -25186,7 +25307,7 @@
             <a:r>
               <a:rPr lang="de-DE" sz="1150" b="1" dirty="0">
                 <a:solidFill>
-                  <a:srgbClr val="2A3A5E"/>
+                  <a:srgbClr val="FFFFFF"/>
                 </a:solidFill>
                 <a:latin typeface="Calibri" pitchFamily="49" charset="0"/>
               </a:rPr>
@@ -25238,7 +25359,11 @@
           <a:lstStyle/>
           <a:p>
             <a:r>
-              <a:rPr lang="de-DE" sz="800" dirty="0"/>
+              <a:rPr lang="de-DE" sz="800" dirty="0">
+                <a:solidFill>
+                  <a:srgbClr val="FFFFFF"/>
+                </a:solidFill>
+              </a:rPr>
               <a:t>8</a:t>
             </a:r>
           </a:p>
@@ -26988,7 +27113,7 @@
           </a:solidFill>
           <a:ln w="6350">
             <a:solidFill>
-              <a:srgbClr val="2A3A5E"/>
+              <a:srgbClr val="D0D7E8"/>
             </a:solidFill>
             <a:prstDash val="solid"/>
           </a:ln>
@@ -27578,7 +27703,7 @@
             <a:r>
               <a:rPr lang="en-US" sz="800" dirty="0">
                 <a:solidFill>
-                  <a:srgbClr val="E94560"/>
+                  <a:srgbClr val="FFFFFF"/>
                 </a:solidFill>
                 <a:latin typeface="Calibri" pitchFamily="34" charset="0"/>
                 <a:ea typeface="Calibri" pitchFamily="34" charset="-122"/>

</xml_diff>